<commit_message>
Reframe case-17 deck around two explicit theses
Часть 1 (workstation agent): "ГДЕ" -> "ЕСТЬ СОМНЕНИЯ В НЕОБХОДИМОСТИ" --
reframed from a neutral open technical question to a soft, evidence-led
doubt about whether the feature is necessary as currently scoped; the
4 vendor questions (case-11 Вопрос 1) stay verbatim, now framed as what
would need to be answered to resolve the doubt.

Часть 2 (catalog hierarchy): "НАСКОЛЬКО ТОЧНО" -> "ПРЕДЛОЖЕНИЕ К
РЕАЛИЗАЦИИ" -- reframed from a hedged open question to a confident,
ready-to-implement proposal; remaining open sub-questions (multi-node
binding, tree restructuring, cross-domain sharing) reframed as
implementation details to work out together rather than reasons to
doubt the proposal.

Touched slides 2-7, 9, 11, 14-18; left factual/diagram-only slides
(1, 8, 10, 12, 13) unchanged.

Co-Authored-By: Claude Sonnet 5 <noreply@anthropic.com>
Claude-Session: https://claude.ai/code/session_01DpSN8JwCJ3tg3JVUadr2zE
</commit_message>
<xml_diff>
--- a/docs/presentations/case-17-lokalny-chat-i-ierarhiya-katalogov.pptx
+++ b/docs/presentations/case-17-lokalny-chat-i-ierarhiya-katalogov.pptx
@@ -695,7 +695,7 @@
           <a:p>
             <a:r>
               <a:rPr lang="en-US" dirty="0"/>
-              <a:t>Новый слайд — прямой ответ на замечание пользователя после просмотра дерева: каталог может по смыслу принадлежать больше чем одному домену. Точная формулировка, которую важно не смазать: это НЕ исключение из правила «видимость течёт только вниз» — правило продолжает действовать независимо и полностью внутри каждого домена (персона на корне «Кадры» видит «Список сотрудников» по обычному нисходящему наследованию, точно так же персона в «Продажи»). Новое — только то, что один и тот же узел может быть нисходяще достижимым сразу в двух разных деревьях одновременно, то есть иметь двух родителей, а не одного. Это зеркальный случай вопросу 4 из case-11 (там — доступ персоны к нескольким несмежным узлам ОДНОГО домена; здесь — членство каталога сразу в НЕСКОЛЬКИХ доменах) и прямая иллюстрация вывода case-19 §5: ни одна из проверенных зрелых систем (SharePoint, Google Drive, Purview, Databricks) не обошлась без отдельного механизма для похожего кросс-веточного/кросс-доменного случая — это стоит поднять с вендором как открытый архитектурный вопрос, а не решать самим деревом.</a:t>
+              <a:t>Новый слайд — прямой ответ на замечание пользователя после просмотра дерева: каталог может по смыслу принадлежать больше чем одному домену. Точная формулировка, которую важно не смазать: это НЕ исключение из правила «видимость течёт только вниз» — правило продолжает действовать независимо и полностью внутри каждого домена (персона на корне «Кадры» видит «Список сотрудников» по обычному нисходящему наследованию, точно так же персона в «Продажи»). Новое — только то, что один и тот же узел может быть нисходяще достижимым сразу в двух разных деревьях одновременно, то есть иметь двух родителей, а не одного. Это зеркальный случай вопросу 4 из case-11 (там — доступ персоны к нескольким несмежным узлам ОДНОГО домена; здесь — членство каталога сразу в НЕСКОЛЬКИХ доменах) и прямая иллюстрация вывода case-19 §5: ни одна из проверенных зрелых систем (SharePoint, Google Drive, Purview, Databricks) не обошлась без отдельного механизма для похожего кросс-веточного/кросс-доменного случая. Это не повод сомневаться в самом предложении дерева — это конкретная реализационная деталь, которую честнее поднять сейчас и решить вместе с вендором, чем сделать вид, что её не существует.</a:t>
             </a:r>
             <a:endParaRPr lang="en-US" dirty="0"/>
           </a:p>
@@ -959,7 +959,7 @@
           <a:p>
             <a:r>
               <a:rPr lang="en-US" dirty="0"/>
-              <a:t>Обновлено по итогам case-19/case-20: раньше средний пункт был непроверенным утверждением «давно стандартно в DMS/DAM-системах» без единого названного продукта (справедливо раскритиковано в case-20, §3). Теперь — конкретные, названные прецеденты из case-19: Microsoft Purview (самый близкий — есть буквально функция «Restrict inherited permissions» и тот же инвариант «корень нельзя ограничить»), Google Drive («Limited access»/«Expansive access»), SharePoint («break inheritance»), Databricks Unity Catalog (наследование по catalog.schema.table). Первый пункт также уточнён: предложение решает 2b (организация доменов), а не 2a (гранулярность внутри документа) — это два разных вопроса вендору, разница объяснена на предыдущем слайде.</a:t>
+              <a:t>Обновлено по итогам case-19/case-20: раньше средний пункт был непроверенным утверждением «давно стандартно в DMS/DAM-системах» без единого названного продукта (справедливо раскритиковано в case-20, §3). Теперь — конкретные, названные прецеденты из case-19: Microsoft Purview (самый близкий — есть буквально функция «Restrict inherited permissions» и тот же инвариант «корень нельзя ограничить»), Google Drive («Limited access»/«Expansive access»), SharePoint («break inheritance»), Databricks Unity Catalog (наследование по catalog.schema.table). Первый пункт также уточнён: предложение решает 2b (организация доменов), а не 2a (гранулярность внутри документа) — это два разных вопроса вендору, разница объяснена на предыдущем слайде. Это опора для уверенного тона части 2: мы предлагаем не гипотезу, а модель, чьё поведение по умолчанию уже проверено в нескольких независимо развивавшихся системах.</a:t>
             </a:r>
             <a:endParaRPr lang="en-US" dirty="0"/>
           </a:p>
@@ -1047,7 +1047,7 @@
           <a:p>
             <a:r>
               <a:rPr lang="en-US" dirty="0"/>
-              <a:t>Важно подчеркнуть: это предложение — не блокер для текущего пилота Д8. Сегодняшний обходной путь (несколько коллекций с отдельными доменами вместо одного дерева) полностью рабочий, просто требует больше ручного планирования на старте и создаёт риск, что несколько независимых коллекций/доменов со временем разъедутся по составу прав.</a:t>
+              <a:t>Важно подчеркнуть: предложение не блокер для текущего пилота Д8 и не повод откладывать его до реализации дерева. Сегодняшний обходной путь (несколько коллекций с отдельными доменами вместо одного дерева) полностью рабочий, просто требует больше ручного планирования на старте и создаёт риск, что несколько независимых коллекций/доменов со временем разъедутся по составу прав — именно это неудобство и снимает предложенное дерево.</a:t>
             </a:r>
             <a:endParaRPr lang="en-US" dirty="0"/>
           </a:p>
@@ -1135,7 +1135,7 @@
           <a:p>
             <a:r>
               <a:rPr lang="en-US" dirty="0"/>
-              <a:t>Формулировка статуса намеренная: это предложение для дорожной карты, поданное в сторону вендора как готовая для обсуждения модель, а не жалоба на текущую функциональность. В case-11 пункт явно не привязан к конкретному коду роадмапа — предполагаем линию «Каталог» (КАТ-) или «Надзор» (НАД-) как наиболее вероятных кандидатов.</a:t>
+              <a:t>Формулировка статуса намеренная и увереннее, чем раньше: это готовое предложение к реализации, поданное вендору как модель, которую мы предлагаем включить в дорожную карту, а не жалоба на текущую функциональность и не гипотеза для обсуждения «стоит ли вообще». Открытые детали (двойное членство каталогов, реструктуризация дерева, множественная привязка персон) остаются реальными и честно названы на предыдущих слайдах — но как то, что дорабатывается вместе с вендором в процессе реализации, а не как причины сомневаться в самом предложении. В case-11 пункт явно не привязан к конкретному коду роадмапа — предполагаем линию «Каталог» (КАТ-) или «Надзор» (НАД-) как наиболее вероятных кандидатов.</a:t>
             </a:r>
             <a:endParaRPr lang="en-US" dirty="0"/>
           </a:p>
@@ -1223,7 +1223,7 @@
           <a:p>
             <a:r>
               <a:rPr lang="en-US" dirty="0"/>
-              <a:t>Слайд-синтез, связывающий обе части: и локальный чат, и иерархия каталогов — про одну и ту же границу между тем, что платформа уже гарантирует документированно, и тем, что нужно уточнить по мере роста поверхности платформы (новое место исполнения; более тонкая гранулярность доступа). Оба вопроса поднимаются заранее, пока ни один не стал контрактным обязательством.</a:t>
+              <a:t>Слайд-синтез, связывающий обе части и явно называющий две разные позиции по ним: и локальный чат, и иерархия каталогов — про одну и ту же границу между тем, что платформа уже гарантирует документированно, и тем, что нужно решить по мере роста поверхности платформы. Но решаются они по-разному: Часть 1 (новое место исполнения) — это открытый вопрос вендору, наше сомнение в необходимости; Часть 2 (более тонкая гранулярность доступа) — это наше предложение к реализации, которое мы считаем готовым. Оба поднимаются заранее, пока ни один не стал контрактным обязательством.</a:t>
             </a:r>
             <a:endParaRPr lang="en-US" dirty="0"/>
           </a:p>
@@ -1311,7 +1311,7 @@
           <a:p>
             <a:r>
               <a:rPr lang="en-US" dirty="0"/>
-              <a:t>Закрывающий слайд. Единственный источник фактов для обеих тем этой колоды — case-11-voprosy-vendoru-roadmap.md; он же станет местом, куда будут добавлены ответы вендора по мере их получения, и куда попадут следующие вопросы по дорожной карте по мере разбора остальных пунктов.</a:t>
+              <a:t>Закрывающий слайд, явно фиксирующий две разные позиции колоды: Часть 1 — открытый вопрос вендору о необходимости РМ-1 в заявленном виде, ответа пока нет; Часть 2 — наше предложение к реализации, которое мы считаем проработанным и готовы обсуждать детали. Единственный источник фактов для обеих тем — case-11-voprosy-vendoru-roadmap.md; он же станет местом, куда будут добавлены ответы вендора по мере их получения, и куда попадут следующие вопросы по дорожной карте по мере разбора остальных пунктов.</a:t>
             </a:r>
             <a:endParaRPr lang="en-US" dirty="0"/>
           </a:p>
@@ -1399,7 +1399,7 @@
           <a:p>
             <a:r>
               <a:rPr lang="en-US" dirty="0"/>
-              <a:t>Смысл слайда — объяснить, зачем два, на первый взгляд, разных вопроса объединены в одну колоду. Общий знаменатель: оба — про расширение границ контроля доступа за пределы того, что сегодня документировано. Часть 1 — новое МЕСТО исполнения (компьютер сотрудника вместо сервера). Часть 2 — новая ГРАНУЛЯРНОСТЬ (узел дерева вместо целой коллекции). Оба вопроса уже вошли в пакет вопросов вендору (case-11).</a:t>
+              <a:t>Смысл слайда — сразу задать две разные позиции по двум темам, а не подавать обе как одинаково открытые вопросы. Часть 1 (локальный чат / агент рабочей станции, РМ-1): у нас есть сомнения, нужно ли это расширение в заявленном виде, пока не решён вопрос о защите данных на компьютере сотрудника — это диалог с вендором, а не отказ от функции. Часть 2 (иерархия каталогов): у нас есть проработанная модель (дерево каталогов), которую мы считаем достаточно зрелой, чтобы предлагать её в дорожную карту и обсуждать детали реализации, а не решать, стоит ли вообще что-то делать. Оба уже зафиксированы в пакете вопросов вендору (case-11).</a:t>
             </a:r>
             <a:endParaRPr lang="en-US" dirty="0"/>
           </a:p>
@@ -1487,7 +1487,7 @@
           <a:p>
             <a:r>
               <a:rPr lang="en-US" dirty="0"/>
-              <a:t>Раздел-разделитель. Дальше — три плотных слайда о линии «Раб. места» дорожной карты (сознательно сокращено с восьми — часть 1 не должна разворачиваться дольше, чем нужно для передачи технического запроса): что это и какие четыре пункта в неё входят, четыре уточняющих вопроса вендору, и почему это важно с закрывающим статусом.</a:t>
+              <a:t>Раздел-разделитель. Дальше — три плотных слайда о линии «Раб. места» дорожной карты (сознательно сокращено с восьми — часть 1 не должна разворачиваться дольше, чем нужно для передачи технического запроса): что это и какие четыре пункта в неё входят, четыре вопроса вендору, ответы на которые снимут или подтвердят сомнение, и почему сомнение вообще возникло — с закрывающим статусом. Тон намеренно мягкий: это не рекомендация отказаться от РМ-1, а вопрос, который вендор может закрыть ответом.</a:t>
             </a:r>
             <a:endParaRPr lang="en-US" dirty="0"/>
           </a:p>
@@ -1575,7 +1575,7 @@
           <a:p>
             <a:r>
               <a:rPr lang="en-US" dirty="0"/>
-              <a:t>Слайд объединяет «что это» и «четыре пункта роадмапа» в одну плотную карточку — раньше это были два отдельных слайда с большим количеством повторяющегося текста. Ключевая мысль сохранена: новое место исполнения — не улучшение серверного чата, а второй контур обработки данных (компьютер сотрудника). РМ-1 и РМ-2 — оба Q1 2027, уровень C (направление подтверждено, состав уточняется, не обязательство со сроками). РМ-3 — Q2 2027, C. РМ-4 — H2 2027, уровень D, пустая формулировка без состава — не читать в это ничего конкретного.</a:t>
+              <a:t>Слайд объединяет «что это» и «четыре пункта роадмапа» в одну плотную карточку — раньше это были два отдельных слайда с большим количеством повторяющегося текста. Ключевая мысль сохранена: новое место исполнения — не улучшение серверного чата, а второй контур обработки данных (компьютер сотрудника). РМ-1 и РМ-2 — оба Q1 2027, уровень C (направление подтверждено, состав уточняется, не обязательство со сроками). РМ-3 — Q2 2027, C. РМ-4 — H2 2027, уровень D, пустая формулировка без состава — не читать в это ничего конкретного. Наши сомнения сосредоточены именно в РМ-1 (модель запретов и судьба разрешённого содержимого) — не в самой идее агента рабочей станции как таковой.</a:t>
             </a:r>
             <a:endParaRPr lang="en-US" dirty="0"/>
           </a:p>
@@ -1663,7 +1663,7 @@
           <a:p>
             <a:r>
               <a:rPr lang="en-US" dirty="0"/>
-              <a:t>Все четыре формулировки — дословно из Вопроса 1 в case-11-voprosy-vendoru-roadmap.md, содержание не сокращалось. Порядок сохранён: (1) применяется ли то же маскирование, (2) действует ли то же правило про внешние/облачные модели, (3) кто задаёт запреты — админ или сам пользователь, (4) единый ли журнал аудита. Это основной содержательный слайд части 1 — вокруг него специально убраны декоративные слайды-подводки.</a:t>
+              <a:t>Все четыре формулировки — дословно из Вопроса 1 в case-11-voprosy-vendoru-roadmap.md, содержание не сокращалось и не смягчалось. Порядок сохранён: (1) применяется ли то же маскирование, (2) действует ли то же правило про внешние/облачные модели, (3) кто задаёт запреты — админ или сам пользователь, (4) единый ли журнал аудита. Это основной содержательный слайд части 1: раньше подавался как «уточняющие вопросы к уже принятому пункту», теперь — как условия, при выполнении которых наше сомнение в необходимости РМ-1 снимается. Вокруг него специально убраны декоративные слайды-подводки.</a:t>
             </a:r>
             <a:endParaRPr lang="en-US" dirty="0"/>
           </a:p>
@@ -1751,7 +1751,7 @@
           <a:p>
             <a:r>
               <a:rPr lang="en-US" dirty="0"/>
-              <a:t>Это наша внутренняя оценка (не для передачи вендору как есть, только для собственной подготовки) — из всех 35 пунктов дорожной карты это единственный, где рядом с новой функцией явно не упомянута уже заявленная модель защиты данных. Слайд объединяет аргумент «почему важно» с закрывающим статусом части 1 — отдельного слайда-итога больше нет, статус дан одной строкой внизу: вопрос сформулирован, ответа вендора пока нет, уровень C — не обязательство по срокам.</a:t>
+              <a:t>Это наша внутренняя оценка (не для передачи вендору как есть, только для собственной подготовки) — из всех 35 пунктов дорожной карты это единственный, где рядом с новой функцией явно не упомянута уже заявленная модель защиты данных, и это главная опора нашего сомнения в необходимости РМ-1 в текущем виде. Слайд объединяет аргумент «почему сомнение возникло» с закрывающим статусом части 1 — отдельного слайда-итога больше нет, статус дан одной строкой внизу: это открытый вопрос вендору, а не рекомендация отказаться от пункта; уровень C — не обязательство по срокам, так что сейчас подходящий момент спросить.</a:t>
             </a:r>
             <a:endParaRPr lang="en-US" dirty="0"/>
           </a:p>
@@ -1839,7 +1839,7 @@
           <a:p>
             <a:r>
               <a:rPr lang="en-US" dirty="0"/>
-              <a:t>Раздел-разделитель. Дальше — десять слайдов: сегодняшняя плоская модель доменов/коллекций, где она упирается в реальный сценарий (с явным разделением на два разных вопроса — 2a и 2b, по пересмотру case-11/case-20), дерево каталогов как предложение по 2b с ключевой диаграммой, отдельный слайд про кросс-доменное пересечение коллекций (случай, который дерево не решает само по себе), правило наследования, три персоны на новом дереве, почему предложение реалистично — с прецедентами из case-19, и что остаётся в силе, пока предложение не реализовано.</a:t>
+              <a:t>Раздел-разделитель. Дальше — десять слайдов: сегодняшняя плоская модель доменов/коллекций, где она упирается в реальный сценарий (с явным разделением на два разных вопроса — 2a и 2b, по пересмотру case-11/case-20), дерево каталогов как готовое предложение по 2b с ключевой диаграммой, отдельный слайд про кросс-доменное пересечение коллекций (деталь, которую доработаем вместе с вендором при реализации), правило наследования, три персоны на новом дереве, почему предложение реалистично — с прецедентами из case-19, и что остаётся в силе, пока идём к реализации. Тон части 2 — увереннее, чем части 1: это не вопрос «стоит ли», а предложение «вот модель, готовы прорабатывать детали».</a:t>
             </a:r>
             <a:endParaRPr lang="en-US" dirty="0"/>
           </a:p>
@@ -4643,7 +4643,7 @@
                 <a:ea typeface="Calibri" pitchFamily="34" charset="-122"/>
                 <a:cs typeface="Calibri" pitchFamily="34" charset="-120"/>
               </a:rPr>
-              <a:t>ЧАСТЬ 2 · ОТКРЫТЫЙ МОМЕНТ</a:t>
+              <a:t>ЧАСТЬ 2 · УТОЧНИМ ВМЕСТЕ ПРИ РЕАЛИЗАЦИИ</a:t>
             </a:r>
             <a:endParaRPr lang="en-US" sz="1150" dirty="0"/>
           </a:p>
@@ -5332,12 +5332,12 @@
           <a:p>
             <a:pPr indent="0" marL="0">
               <a:lnSpc>
-                <a:spcPct val="126000"/>
+                <a:spcPct val="124000"/>
               </a:lnSpc>
               <a:buNone/>
             </a:pPr>
             <a:r>
-              <a:rPr lang="en-US" sz="1150" b="1" dirty="0">
+              <a:rPr lang="en-US" sz="1100" b="1" dirty="0">
                 <a:solidFill>
                   <a:srgbClr val="B87A1E"/>
                 </a:solidFill>
@@ -5345,16 +5345,16 @@
                 <a:ea typeface="Calibri" pitchFamily="34" charset="-122"/>
                 <a:cs typeface="Calibri" pitchFamily="34" charset="-120"/>
               </a:rPr>
-              <a:t>Открытый момент для вендора: </a:t>
+              <a:t>Деталь для совместной проработки при реализации: </a:t>
             </a:r>
             <a:pPr indent="0" marL="0">
               <a:lnSpc>
-                <a:spcPct val="126000"/>
+                <a:spcPct val="124000"/>
               </a:lnSpc>
               <a:buNone/>
             </a:pPr>
             <a:r>
-              <a:rPr lang="en-US" sz="1150" dirty="0">
+              <a:rPr lang="en-US" sz="1100" dirty="0">
                 <a:solidFill>
                   <a:srgbClr val="1B1E27"/>
                 </a:solidFill>
@@ -5366,12 +5366,12 @@
             </a:r>
             <a:pPr indent="0" marL="0">
               <a:lnSpc>
-                <a:spcPct val="126000"/>
+                <a:spcPct val="124000"/>
               </a:lnSpc>
               <a:buNone/>
             </a:pPr>
             <a:r>
-              <a:rPr lang="en-US" sz="1150" b="1" dirty="0">
+              <a:rPr lang="en-US" sz="1100" b="1" dirty="0">
                 <a:solidFill>
                   <a:srgbClr val="1B1E27"/>
                 </a:solidFill>
@@ -5383,12 +5383,12 @@
             </a:r>
             <a:pPr indent="0" marL="0">
               <a:lnSpc>
-                <a:spcPct val="126000"/>
+                <a:spcPct val="124000"/>
               </a:lnSpc>
               <a:buNone/>
             </a:pPr>
             <a:r>
-              <a:rPr lang="en-US" sz="1150" dirty="0">
+              <a:rPr lang="en-US" sz="1100" dirty="0">
                 <a:solidFill>
                   <a:srgbClr val="1B1E27"/>
                 </a:solidFill>
@@ -5396,9 +5396,9 @@
                 <a:ea typeface="Calibri" pitchFamily="34" charset="-122"/>
                 <a:cs typeface="Calibri" pitchFamily="34" charset="-120"/>
               </a:rPr>
-              <a:t> — см. case-19, §5.</a:t>
-            </a:r>
-            <a:endParaRPr lang="en-US" sz="1150" dirty="0"/>
+              <a:t> — см. case-19, §5. Предложение дерева от этого не меняется, только это конкретное решение стоит выбрать вместе с вендором.</a:t>
+            </a:r>
+            <a:endParaRPr lang="en-US" sz="1100" dirty="0"/>
           </a:p>
         </p:txBody>
       </p:sp>
@@ -7690,7 +7690,7 @@
                 <a:ea typeface="Calibri" pitchFamily="34" charset="-122"/>
                 <a:cs typeface="Calibri" pitchFamily="34" charset="-120"/>
               </a:rPr>
-              <a:t>ЧАСТЬ 2 · ПОЧЕМУ ЭТО РЕАЛИСТИЧНЫЙ ЗАПРОС</a:t>
+              <a:t>ЧАСТЬ 2 · ПОЧЕМУ ЭТО РЕАЛИСТИЧНОЕ ПРЕДЛОЖЕНИЕ</a:t>
             </a:r>
             <a:endParaRPr lang="en-US" sz="1150" dirty="0"/>
           </a:p>
@@ -7732,7 +7732,7 @@
                 <a:ea typeface="Cambria" pitchFamily="34" charset="-122"/>
                 <a:cs typeface="Cambria" pitchFamily="34" charset="-120"/>
               </a:rPr>
-              <a:t>Не просто идея — подкреплена проверенными прецедентами</a:t>
+              <a:t>Не просто идея — предложение подкреплено проверенными прецедентами</a:t>
             </a:r>
             <a:endParaRPr lang="en-US" sz="2900" dirty="0"/>
           </a:p>
@@ -8367,7 +8367,7 @@
                 <a:ea typeface="Calibri" pitchFamily="34" charset="-122"/>
                 <a:cs typeface="Calibri" pitchFamily="34" charset="-120"/>
               </a:rPr>
-              <a:t>ЧАСТЬ 2 · ПОКА НЕ РЕАЛИЗОВАНО</a:t>
+              <a:t>ЧАСТЬ 2 · ДО РЕАЛИЗАЦИИ</a:t>
             </a:r>
             <a:endParaRPr lang="en-US" sz="1150" dirty="0"/>
           </a:p>
@@ -8409,7 +8409,7 @@
                 <a:ea typeface="Cambria" pitchFamily="34" charset="-122"/>
                 <a:cs typeface="Cambria" pitchFamily="34" charset="-120"/>
               </a:rPr>
-              <a:t>Что остаётся в силе сегодня, пока предложение не принято</a:t>
+              <a:t>Что остаётся в силе сегодня, пока предложение не реализовано</a:t>
             </a:r>
             <a:endParaRPr lang="en-US" sz="2900" dirty="0"/>
           </a:p>
@@ -8999,7 +8999,7 @@
                 <a:ea typeface="Cambria" pitchFamily="34" charset="-122"/>
                 <a:cs typeface="Cambria" pitchFamily="34" charset="-120"/>
               </a:rPr>
-              <a:t>Статус: предложение для roadmap, а не отчёт о дефекте</a:t>
+              <a:t>Статус: предложение к реализации, а не отчёт о дефекте</a:t>
             </a:r>
             <a:endParaRPr lang="en-US" sz="2900" dirty="0"/>
           </a:p>
@@ -9048,7 +9048,7 @@
         <p:spPr>
           <a:xfrm>
             <a:off x="914400" y="2103120"/>
-            <a:ext cx="2651760" cy="457200"/>
+            <a:ext cx="3063240" cy="457200"/>
           </a:xfrm>
           <a:prstGeom prst="roundRect">
             <a:avLst>
@@ -9070,7 +9070,7 @@
         <p:spPr>
           <a:xfrm>
             <a:off x="960120" y="2103120"/>
-            <a:ext cx="2560320" cy="457200"/>
+            <a:ext cx="2971800" cy="457200"/>
           </a:xfrm>
           <a:prstGeom prst="rect">
             <a:avLst/>
@@ -9094,7 +9094,7 @@
                 <a:ea typeface="Calibri" pitchFamily="34" charset="-122"/>
                 <a:cs typeface="Calibri" pitchFamily="34" charset="-120"/>
               </a:rPr>
-              <a:t>Roadmap-предложение</a:t>
+              <a:t>Предложение к реализации</a:t>
             </a:r>
             <a:endParaRPr lang="en-US" sz="1300" dirty="0"/>
           </a:p>
@@ -9123,12 +9123,12 @@
           <a:p>
             <a:pPr indent="0" marL="0">
               <a:lnSpc>
-                <a:spcPct val="126000"/>
+                <a:spcPct val="124000"/>
               </a:lnSpc>
               <a:buNone/>
             </a:pPr>
             <a:r>
-              <a:rPr lang="en-US" sz="1300" dirty="0">
+              <a:rPr lang="en-US" sz="1250" dirty="0">
                 <a:solidFill>
                   <a:srgbClr val="1B1E27"/>
                 </a:solidFill>
@@ -9136,9 +9136,9 @@
                 <a:ea typeface="Calibri" pitchFamily="34" charset="-122"/>
                 <a:cs typeface="Calibri" pitchFamily="34" charset="-120"/>
               </a:rPr>
-              <a:t>Это не найденный баг и не пробел в тестировании — а естественное расширение сегодняшней модели «домен = тематическая область», подкреплённое конкретными прецедентами (case-19), которое предлагается обсудить с вендором предметно.</a:t>
-            </a:r>
-            <a:endParaRPr lang="en-US" sz="1300" dirty="0"/>
+              <a:t>Это не найденный баг и не пробел в тестировании — а естественное расширение сегодняшней модели «домен = тематическая область», подкреплённое конкретными прецедентами (case-19). Мы предлагаем включить его в дорожную карту и готовы прорабатывать детали реализации вместе с вендором.</a:t>
+            </a:r>
+            <a:endParaRPr lang="en-US" sz="1250" dirty="0"/>
           </a:p>
         </p:txBody>
       </p:sp>
@@ -9361,7 +9361,7 @@
               <a:buNone/>
             </a:pPr>
             <a:r>
-              <a:rPr lang="en-US" sz="2900" b="1" dirty="0">
+              <a:rPr lang="en-US" sz="2700" b="1" dirty="0">
                 <a:solidFill>
                   <a:srgbClr val="1B1E27"/>
                 </a:solidFill>
@@ -9369,9 +9369,9 @@
                 <a:ea typeface="Cambria" pitchFamily="34" charset="-122"/>
                 <a:cs typeface="Cambria" pitchFamily="34" charset="-120"/>
               </a:rPr>
-              <a:t>Одна и та же граница: что уже гарантировано, и что требует уточнения по мере роста платформы</a:t>
-            </a:r>
-            <a:endParaRPr lang="en-US" sz="2900" dirty="0"/>
+              <a:t>Одна и та же граница контроля доступа — два разных ответа: сомнение и предложение</a:t>
+            </a:r>
+            <a:endParaRPr lang="en-US" sz="2700" dirty="0"/>
           </a:p>
         </p:txBody>
       </p:sp>
@@ -9665,7 +9665,7 @@
                 <a:ea typeface="Cambria" pitchFamily="34" charset="-122"/>
                 <a:cs typeface="Cambria" pitchFamily="34" charset="-120"/>
               </a:rPr>
-              <a:t>Требует уточнения по мере роста</a:t>
+              <a:t>Две разные позиции</a:t>
             </a:r>
             <a:endParaRPr lang="en-US" sz="1550" dirty="0"/>
           </a:p>
@@ -9694,12 +9694,12 @@
           <a:p>
             <a:pPr indent="0" marL="0">
               <a:lnSpc>
-                <a:spcPct val="140000"/>
+                <a:spcPct val="132000"/>
               </a:lnSpc>
               <a:buNone/>
             </a:pPr>
             <a:r>
-              <a:rPr lang="en-US" sz="1300" dirty="0">
+              <a:rPr lang="en-US" sz="1200" dirty="0">
                 <a:solidFill>
                   <a:srgbClr val="1B1E27"/>
                 </a:solidFill>
@@ -9707,19 +9707,19 @@
                 <a:ea typeface="Calibri" pitchFamily="34" charset="-122"/>
                 <a:cs typeface="Calibri" pitchFamily="34" charset="-120"/>
               </a:rPr>
-              <a:t>• Новое место исполнения — компьютер сотрудника (Часть 1)</a:t>
-            </a:r>
-            <a:endParaRPr lang="en-US" sz="1300" dirty="0"/>
+              <a:t>• Часть 1 — сомнение в необходимости нового места исполнения (компьютер сотрудника); ждём ответа вендора</a:t>
+            </a:r>
+            <a:endParaRPr lang="en-US" sz="1200" dirty="0"/>
           </a:p>
           <a:p>
             <a:pPr indent="0" marL="0">
               <a:lnSpc>
-                <a:spcPct val="140000"/>
+                <a:spcPct val="132000"/>
               </a:lnSpc>
               <a:buNone/>
             </a:pPr>
             <a:r>
-              <a:rPr lang="en-US" sz="1300" dirty="0">
+              <a:rPr lang="en-US" sz="1200" dirty="0">
                 <a:solidFill>
                   <a:srgbClr val="1B1E27"/>
                 </a:solidFill>
@@ -9727,9 +9727,9 @@
                 <a:ea typeface="Calibri" pitchFamily="34" charset="-122"/>
                 <a:cs typeface="Calibri" pitchFamily="34" charset="-120"/>
               </a:rPr>
-              <a:t>• Более тонкая гранулярность доступа, чем плоский домен способен выразить (Часть 2)</a:t>
-            </a:r>
-            <a:endParaRPr lang="en-US" sz="1300" dirty="0"/>
+              <a:t>• Часть 2 — предложение к реализации, снимающее ограничение плоского домена; готовы дорабатывать вместе</a:t>
+            </a:r>
+            <a:endParaRPr lang="en-US" sz="1200" dirty="0"/>
           </a:p>
         </p:txBody>
       </p:sp>
@@ -9755,10 +9755,13 @@
           <a:lstStyle/>
           <a:p>
             <a:pPr algn="ctr" indent="0" marL="0">
-              <a:buNone/>
-            </a:pPr>
-            <a:r>
-              <a:rPr lang="en-US" sz="1350" b="1" i="1" dirty="0">
+              <a:lnSpc>
+                <a:spcPct val="120000"/>
+              </a:lnSpc>
+              <a:buNone/>
+            </a:pPr>
+            <a:r>
+              <a:rPr lang="en-US" sz="1300" b="1" i="1" dirty="0">
                 <a:solidFill>
                   <a:srgbClr val="1B1E27"/>
                 </a:solidFill>
@@ -9766,9 +9769,9 @@
                 <a:ea typeface="Calibri" pitchFamily="34" charset="-122"/>
                 <a:cs typeface="Calibri" pitchFamily="34" charset="-120"/>
               </a:rPr>
-              <a:t>Оба вопроса поднимаются проактивно — до того, как любой из них станет жёстким обязательством в договоре.</a:t>
-            </a:r>
-            <a:endParaRPr lang="en-US" sz="1350" dirty="0"/>
+              <a:t>Часть 1 остаётся открытым вопросом для вендора, Часть 2 — предложением к реализации. Обе позиции поднимаются проактивно, до того как РМ-1 или «Каталог»/«Надзор» станут обязательством в договоре.</a:t>
+            </a:r>
+            <a:endParaRPr lang="en-US" sz="1300" dirty="0"/>
           </a:p>
         </p:txBody>
       </p:sp>
@@ -10001,7 +10004,7 @@
                 <a:ea typeface="Cambria" pitchFamily="34" charset="-122"/>
                 <a:cs typeface="Cambria" pitchFamily="34" charset="-120"/>
               </a:rPr>
-              <a:t>Оба вопроса отслеживаются в одном файле</a:t>
+              <a:t>Сомнение и предложение — в одном файле</a:t>
             </a:r>
             <a:endParaRPr lang="en-US" sz="3000" dirty="0"/>
           </a:p>
@@ -10016,7 +10019,7 @@
         <p:spPr>
           <a:xfrm>
             <a:off x="548640" y="3246120"/>
-            <a:ext cx="7863840" cy="1005840"/>
+            <a:ext cx="7863840" cy="1051560"/>
           </a:xfrm>
           <a:prstGeom prst="rect">
             <a:avLst/>
@@ -10030,12 +10033,12 @@
           <a:p>
             <a:pPr indent="0" marL="0">
               <a:lnSpc>
-                <a:spcPct val="135000"/>
+                <a:spcPct val="130000"/>
               </a:lnSpc>
               <a:buNone/>
             </a:pPr>
             <a:r>
-              <a:rPr lang="en-US" sz="1500" dirty="0">
+              <a:rPr lang="en-US" sz="1450" dirty="0">
                 <a:solidFill>
                   <a:srgbClr val="AEB4C4"/>
                 </a:solidFill>
@@ -10043,9 +10046,9 @@
                 <a:ea typeface="Calibri" pitchFamily="34" charset="-122"/>
                 <a:cs typeface="Calibri" pitchFamily="34" charset="-120"/>
               </a:rPr>
-              <a:t>case-11-voprosy-vendoru-roadmap.md — источник обеих формулировок в этой колоде. Туда же лягут ответы вендора по мере поступления, и обсуждение продолжится в этом же файле.</a:t>
-            </a:r>
-            <a:endParaRPr lang="en-US" sz="1500" dirty="0"/>
+              <a:t>Часть 1 остаётся открытым вопросом о необходимости — ждём точку зрения вендора. Часть 2 — наше предложение к реализации, готовое дорабатывать вместе. Обе позиции зафиксированы в case-11-voprosy-vendoru-roadmap.md, куда лягут ответы вендора и шаги к реализации.</a:t>
+            </a:r>
+            <a:endParaRPr lang="en-US" sz="1450" dirty="0"/>
           </a:p>
         </p:txBody>
       </p:sp>
@@ -10287,7 +10290,7 @@
               <a:buNone/>
             </a:pPr>
             <a:r>
-              <a:rPr lang="en-US" sz="2900" b="1" dirty="0">
+              <a:rPr lang="en-US" sz="2600" b="1" dirty="0">
                 <a:solidFill>
                   <a:srgbClr val="1B1E27"/>
                 </a:solidFill>
@@ -10295,9 +10298,9 @@
                 <a:ea typeface="Cambria" pitchFamily="34" charset="-122"/>
                 <a:cs typeface="Cambria" pitchFamily="34" charset="-120"/>
               </a:rPr>
-              <a:t>Обе темы — об одном и том же: где именно и насколько точно работает контроль доступа</a:t>
-            </a:r>
-            <a:endParaRPr lang="en-US" sz="2900" dirty="0"/>
+              <a:t>Одна дорожная карта, две разные позиции: сомнение в необходимости и предложение к реализации</a:t>
+            </a:r>
+            <a:endParaRPr lang="en-US" sz="2600" dirty="0"/>
           </a:p>
         </p:txBody>
       </p:sp>
@@ -10324,12 +10327,12 @@
           <a:p>
             <a:pPr indent="0" marL="0">
               <a:lnSpc>
-                <a:spcPct val="130000"/>
+                <a:spcPct val="128000"/>
               </a:lnSpc>
               <a:buNone/>
             </a:pPr>
             <a:r>
-              <a:rPr lang="en-US" sz="1450" dirty="0">
+              <a:rPr lang="en-US" sz="1400" dirty="0">
                 <a:solidFill>
                   <a:srgbClr val="5B6472"/>
                 </a:solidFill>
@@ -10337,9 +10340,9 @@
                 <a:ea typeface="Calibri" pitchFamily="34" charset="-122"/>
                 <a:cs typeface="Calibri" pitchFamily="34" charset="-120"/>
               </a:rPr>
-              <a:t>Платформа документирует контроль доступа для серверной части и на уровне целой коллекции документов. Обе темы ниже — про то, что происходит на границах этой модели: там, где право читать данные не описано архитектурно, либо не может быть выражено достаточно точно.</a:t>
-            </a:r>
-            <a:endParaRPr lang="en-US" sz="1450" dirty="0"/>
+              <a:t>Платформа документирует контроль доступа для серверной части и на уровне целой коллекции документов. Но из этого не следует, что любое расширение этой границы стоит принимать как есть: по локальному чату у нас остаются сомнения, нужно ли расширение в заявленном виде; по иерархии каталогов — наоборот, есть проработанное предложение, которое мы считаем готовым двигать в реализацию.</a:t>
+            </a:r>
+            <a:endParaRPr lang="en-US" sz="1400" dirty="0"/>
           </a:p>
         </p:txBody>
       </p:sp>
@@ -10429,8 +10432,8 @@
         </p:nvSpPr>
         <p:spPr>
           <a:xfrm>
-            <a:off x="1783080" y="2898648"/>
-            <a:ext cx="3703320" cy="274320"/>
+            <a:off x="1755648" y="2880360"/>
+            <a:ext cx="3776472" cy="329184"/>
           </a:xfrm>
           <a:prstGeom prst="rect">
             <a:avLst/>
@@ -10443,10 +10446,13 @@
           <a:lstStyle/>
           <a:p>
             <a:pPr indent="0" marL="0">
-              <a:buNone/>
-            </a:pPr>
-            <a:r>
-              <a:rPr lang="en-US" sz="1100" b="1" spc="120" kern="0" dirty="0">
+              <a:lnSpc>
+                <a:spcPct val="100000"/>
+              </a:lnSpc>
+              <a:buNone/>
+            </a:pPr>
+            <a:r>
+              <a:rPr lang="en-US" sz="1000" b="1" spc="80" kern="0" dirty="0">
                 <a:solidFill>
                   <a:srgbClr val="2F6FED"/>
                 </a:solidFill>
@@ -10454,9 +10460,9 @@
                 <a:ea typeface="Calibri" pitchFamily="34" charset="-122"/>
                 <a:cs typeface="Calibri" pitchFamily="34" charset="-120"/>
               </a:rPr>
-              <a:t>ГДЕ</a:t>
-            </a:r>
-            <a:endParaRPr lang="en-US" sz="1100" dirty="0"/>
+              <a:t>ЕСТЬ СОМНЕНИЯ В НЕОБХОДИМОСТИ</a:t>
+            </a:r>
+            <a:endParaRPr lang="en-US" sz="1000" dirty="0"/>
           </a:p>
         </p:txBody>
       </p:sp>
@@ -10468,8 +10474,8 @@
         </p:nvSpPr>
         <p:spPr>
           <a:xfrm>
-            <a:off x="1783080" y="3154680"/>
-            <a:ext cx="3703320" cy="502920"/>
+            <a:off x="1755648" y="3209544"/>
+            <a:ext cx="3776472" cy="457200"/>
           </a:xfrm>
           <a:prstGeom prst="rect">
             <a:avLst/>
@@ -10485,7 +10491,7 @@
               <a:buNone/>
             </a:pPr>
             <a:r>
-              <a:rPr lang="en-US" sz="1650" b="1" dirty="0">
+              <a:rPr lang="en-US" sz="1600" b="1" dirty="0">
                 <a:solidFill>
                   <a:srgbClr val="1B1E27"/>
                 </a:solidFill>
@@ -10495,7 +10501,7 @@
               </a:rPr>
               <a:t>Часть 1 — локальный чат</a:t>
             </a:r>
-            <a:endParaRPr lang="en-US" sz="1650" dirty="0"/>
+            <a:endParaRPr lang="en-US" sz="1600" dirty="0"/>
           </a:p>
         </p:txBody>
       </p:sp>
@@ -10522,12 +10528,12 @@
           <a:p>
             <a:pPr indent="0" marL="0">
               <a:lnSpc>
-                <a:spcPct val="128000"/>
+                <a:spcPct val="126000"/>
               </a:lnSpc>
               <a:buNone/>
             </a:pPr>
             <a:r>
-              <a:rPr lang="en-US" sz="1300" dirty="0">
+              <a:rPr lang="en-US" sz="1250" dirty="0">
                 <a:solidFill>
                   <a:srgbClr val="5B6472"/>
                 </a:solidFill>
@@ -10535,9 +10541,9 @@
                 <a:ea typeface="Calibri" pitchFamily="34" charset="-122"/>
                 <a:cs typeface="Calibri" pitchFamily="34" charset="-120"/>
               </a:rPr>
-              <a:t>Сегодня защита данных (маскирование PII/DLP) описана для серверной части. Роадмап добавляет второе место исполнения — компьютер сотрудника. Работает ли там та же защита — не описано.</a:t>
-            </a:r>
-            <a:endParaRPr lang="en-US" sz="1300" dirty="0"/>
+              <a:t>Сегодня защита данных (маскирование PII/DLP) описана для серверной части. Роадмап добавляет второе место исполнения — компьютер сотрудника, — и работает ли там та же защита, не описано. Пока это не прояснится, необходимость этого расширения в заявленном виде для нас под вопросом.</a:t>
+            </a:r>
+            <a:endParaRPr lang="en-US" sz="1250" dirty="0"/>
           </a:p>
         </p:txBody>
       </p:sp>
@@ -10627,8 +10633,8 @@
         </p:nvSpPr>
         <p:spPr>
           <a:xfrm>
-            <a:off x="7452360" y="2898648"/>
-            <a:ext cx="3703320" cy="274320"/>
+            <a:off x="7424928" y="2880360"/>
+            <a:ext cx="3776472" cy="329184"/>
           </a:xfrm>
           <a:prstGeom prst="rect">
             <a:avLst/>
@@ -10641,10 +10647,13 @@
           <a:lstStyle/>
           <a:p>
             <a:pPr indent="0" marL="0">
-              <a:buNone/>
-            </a:pPr>
-            <a:r>
-              <a:rPr lang="en-US" sz="1100" b="1" spc="120" kern="0" dirty="0">
+              <a:lnSpc>
+                <a:spcPct val="100000"/>
+              </a:lnSpc>
+              <a:buNone/>
+            </a:pPr>
+            <a:r>
+              <a:rPr lang="en-US" sz="1000" b="1" spc="80" kern="0" dirty="0">
                 <a:solidFill>
                   <a:srgbClr val="B87A1E"/>
                 </a:solidFill>
@@ -10652,9 +10661,9 @@
                 <a:ea typeface="Calibri" pitchFamily="34" charset="-122"/>
                 <a:cs typeface="Calibri" pitchFamily="34" charset="-120"/>
               </a:rPr>
-              <a:t>НАСКОЛЬКО ТОЧНО</a:t>
-            </a:r>
-            <a:endParaRPr lang="en-US" sz="1100" dirty="0"/>
+              <a:t>ПРЕДЛОЖЕНИЕ К РЕАЛИЗАЦИИ</a:t>
+            </a:r>
+            <a:endParaRPr lang="en-US" sz="1000" dirty="0"/>
           </a:p>
         </p:txBody>
       </p:sp>
@@ -10666,8 +10675,8 @@
         </p:nvSpPr>
         <p:spPr>
           <a:xfrm>
-            <a:off x="7452360" y="3154680"/>
-            <a:ext cx="3703320" cy="502920"/>
+            <a:off x="7424928" y="3209544"/>
+            <a:ext cx="3776472" cy="457200"/>
           </a:xfrm>
           <a:prstGeom prst="rect">
             <a:avLst/>
@@ -10683,7 +10692,7 @@
               <a:buNone/>
             </a:pPr>
             <a:r>
-              <a:rPr lang="en-US" sz="1650" b="1" dirty="0">
+              <a:rPr lang="en-US" sz="1600" b="1" dirty="0">
                 <a:solidFill>
                   <a:srgbClr val="1B1E27"/>
                 </a:solidFill>
@@ -10693,7 +10702,7 @@
               </a:rPr>
               <a:t>Часть 2 — иерархия каталогов</a:t>
             </a:r>
-            <a:endParaRPr lang="en-US" sz="1650" dirty="0"/>
+            <a:endParaRPr lang="en-US" sz="1600" dirty="0"/>
           </a:p>
         </p:txBody>
       </p:sp>
@@ -10720,12 +10729,12 @@
           <a:p>
             <a:pPr indent="0" marL="0">
               <a:lnSpc>
-                <a:spcPct val="128000"/>
+                <a:spcPct val="126000"/>
               </a:lnSpc>
               <a:buNone/>
             </a:pPr>
             <a:r>
-              <a:rPr lang="en-US" sz="1300" dirty="0">
+              <a:rPr lang="en-US" sz="1250" dirty="0">
                 <a:solidFill>
                   <a:srgbClr val="5B6472"/>
                 </a:solidFill>
@@ -10733,9 +10742,9 @@
                 <a:ea typeface="Calibri" pitchFamily="34" charset="-122"/>
                 <a:cs typeface="Calibri" pitchFamily="34" charset="-120"/>
               </a:rPr>
-              <a:t>Сегодня доступ к документам делится по целой коллекции. Внутри одной темы разная чувствительность данных выразить нельзя — только дробить на новые, никак не связанные коллекции.</a:t>
-            </a:r>
-            <a:endParaRPr lang="en-US" sz="1300" dirty="0"/>
+              <a:t>Сегодня доступ к документам делится по целой коллекции — внутри одной темы разную чувствительность данных не выразить. У нас есть проработанная модель дерева каталогов, которую мы предлагаем двигать в реализацию.</a:t>
+            </a:r>
+            <a:endParaRPr lang="en-US" sz="1250" dirty="0"/>
           </a:p>
         </p:txBody>
       </p:sp>
@@ -10838,7 +10847,7 @@
               <a:buNone/>
             </a:pPr>
             <a:r>
-              <a:rPr lang="en-US" sz="1250" dirty="0">
+              <a:rPr lang="en-US" sz="1200" dirty="0">
                 <a:solidFill>
                   <a:srgbClr val="1B1E27"/>
                 </a:solidFill>
@@ -10846,7 +10855,7 @@
                 <a:ea typeface="Calibri" pitchFamily="34" charset="-122"/>
                 <a:cs typeface="Calibri" pitchFamily="34" charset="-120"/>
               </a:rPr>
-              <a:t>Обе темы уже зафиксированы как вопросы к вендору в </a:t>
+              <a:t>Обе позиции уже зафиксированы в </a:t>
             </a:r>
             <a:pPr indent="0" marL="0">
               <a:lnSpc>
@@ -10855,7 +10864,7 @@
               <a:buNone/>
             </a:pPr>
             <a:r>
-              <a:rPr lang="en-US" sz="1250" b="1" dirty="0">
+              <a:rPr lang="en-US" sz="1200" b="1" dirty="0">
                 <a:solidFill>
                   <a:srgbClr val="1E4FB8"/>
                 </a:solidFill>
@@ -10872,7 +10881,7 @@
               <a:buNone/>
             </a:pPr>
             <a:r>
-              <a:rPr lang="en-US" sz="1250" dirty="0">
+              <a:rPr lang="en-US" sz="1200" dirty="0">
                 <a:solidFill>
                   <a:srgbClr val="1B1E27"/>
                 </a:solidFill>
@@ -10880,9 +10889,9 @@
                 <a:ea typeface="Calibri" pitchFamily="34" charset="-122"/>
                 <a:cs typeface="Calibri" pitchFamily="34" charset="-120"/>
               </a:rPr>
-              <a:t> — этот файл — источник фактов для всей колоды и живой документ, куда лягут ответы.</a:t>
-            </a:r>
-            <a:endParaRPr lang="en-US" sz="1250" dirty="0"/>
+              <a:t> — Часть 1 как открытый вопрос вендору, Часть 2 как предложение к обсуждению; файл остаётся живым документом, куда лягут ответы и детали реализации.</a:t>
+            </a:r>
+            <a:endParaRPr lang="en-US" sz="1200" dirty="0"/>
           </a:p>
         </p:txBody>
       </p:sp>
@@ -11106,7 +11115,7 @@
         <p:spPr>
           <a:xfrm>
             <a:off x="548640" y="4114800"/>
-            <a:ext cx="8229600" cy="457200"/>
+            <a:ext cx="8686800" cy="640080"/>
           </a:xfrm>
           <a:prstGeom prst="rect">
             <a:avLst/>
@@ -11119,6 +11128,9 @@
           <a:lstStyle/>
           <a:p>
             <a:pPr indent="0" marL="0">
+              <a:lnSpc>
+                <a:spcPct val="125000"/>
+              </a:lnSpc>
               <a:buNone/>
             </a:pPr>
             <a:r>
@@ -11130,7 +11142,7 @@
                 <a:ea typeface="Calibri" pitchFamily="34" charset="-122"/>
                 <a:cs typeface="Calibri" pitchFamily="34" charset="-120"/>
               </a:rPr>
-              <a:t>Агент рабочей станции — линия «Раб. места» (РМ-1—РМ-4), Q1 2027 – H2 2027</a:t>
+              <a:t>Линия «Раб. места» (РМ-1—РМ-4) — прежде чем это станет обязательством, у нас есть сомнения в необходимости</a:t>
             </a:r>
             <a:endParaRPr lang="en-US" sz="1500" dirty="0"/>
           </a:p>
@@ -11394,12 +11406,12 @@
           <a:p>
             <a:pPr indent="0" marL="0">
               <a:lnSpc>
-                <a:spcPct val="128000"/>
+                <a:spcPct val="126000"/>
               </a:lnSpc>
               <a:buNone/>
             </a:pPr>
             <a:r>
-              <a:rPr lang="en-US" sz="1350" dirty="0">
+              <a:rPr lang="en-US" sz="1300" dirty="0">
                 <a:solidFill>
                   <a:srgbClr val="5B6472"/>
                 </a:solidFill>
@@ -11407,9 +11419,9 @@
                 <a:ea typeface="Calibri" pitchFamily="34" charset="-122"/>
                 <a:cs typeface="Calibri" pitchFamily="34" charset="-120"/>
               </a:rPr>
-              <a:t>Сегодня платформа обрабатывает данные только на сервере. Дорожная карта добавляет агент, который выполняется прямо на компьютере сотрудника (Windows, macOS) и читает локальные файлы этой машины как контекст запроса.</a:t>
-            </a:r>
-            <a:endParaRPr lang="en-US" sz="1350" dirty="0"/>
+              <a:t>Сегодня платформа обрабатывает данные только на сервере. Дорожная карта добавляет агент, который выполняется прямо на компьютере сотрудника (Windows, macOS) и читает локальные файлы этой машины как контекст запроса — именно здесь у нас есть сомнения, нужно ли это расширение в заявленном виде (подробнее — на следующих слайдах).</a:t>
+            </a:r>
+            <a:endParaRPr lang="en-US" sz="1300" dirty="0"/>
           </a:p>
         </p:txBody>
       </p:sp>
@@ -12429,7 +12441,7 @@
                 <a:ea typeface="Calibri" pitchFamily="34" charset="-122"/>
                 <a:cs typeface="Calibri" pitchFamily="34" charset="-120"/>
               </a:rPr>
-              <a:t>РМ-1 и РМ-2 идут в один квартал (Q1 2027) не случайно — установка и служба чтения запускаются вместе. РМ-4 — уровень D, честно заявленная заглушка без состава.</a:t>
+              <a:t>РМ-1 — то, где сосредоточены наши сомнения (следующий слайд). РМ-2 идёт с ним в один квартал технически, но сам по себе вопросов не поднимает. РМ-4 — уровень D, честно заявленная заглушка без состава.</a:t>
             </a:r>
             <a:endParaRPr lang="en-US" sz="1150" dirty="0"/>
           </a:p>
@@ -12612,7 +12624,7 @@
               <a:buNone/>
             </a:pPr>
             <a:r>
-              <a:rPr lang="en-US" sz="2900" b="1" dirty="0">
+              <a:rPr lang="en-US" sz="2700" b="1" dirty="0">
                 <a:solidFill>
                   <a:srgbClr val="1B1E27"/>
                 </a:solidFill>
@@ -12620,9 +12632,9 @@
                 <a:ea typeface="Cambria" pitchFamily="34" charset="-122"/>
                 <a:cs typeface="Cambria" pitchFamily="34" charset="-120"/>
               </a:rPr>
-              <a:t>РМ-1 определяет, что нельзя читать. Что с тем, что можно, — предстоит уточнить</a:t>
-            </a:r>
-            <a:endParaRPr lang="en-US" sz="2900" dirty="0"/>
+              <a:t>Что нужно узнать, чтобы сомнение по РМ-1 снялось</a:t>
+            </a:r>
+            <a:endParaRPr lang="en-US" sz="2700" dirty="0"/>
           </a:p>
         </p:txBody>
       </p:sp>
@@ -12634,8 +12646,8 @@
         </p:nvSpPr>
         <p:spPr>
           <a:xfrm>
-            <a:off x="548640" y="1517904"/>
-            <a:ext cx="11094415" cy="548640"/>
+            <a:off x="548640" y="1691640"/>
+            <a:ext cx="11094415" cy="502920"/>
           </a:xfrm>
           <a:prstGeom prst="rect">
             <a:avLst/>
@@ -12649,12 +12661,12 @@
           <a:p>
             <a:pPr indent="0" marL="0">
               <a:lnSpc>
-                <a:spcPct val="126000"/>
+                <a:spcPct val="122000"/>
               </a:lnSpc>
               <a:buNone/>
             </a:pPr>
             <a:r>
-              <a:rPr lang="en-US" sz="1350" dirty="0">
+              <a:rPr lang="en-US" sz="1250" dirty="0">
                 <a:solidFill>
                   <a:srgbClr val="5B6472"/>
                 </a:solidFill>
@@ -12662,9 +12674,9 @@
                 <a:ea typeface="Calibri" pitchFamily="34" charset="-122"/>
                 <a:cs typeface="Calibri" pitchFamily="34" charset="-120"/>
               </a:rPr>
-              <a:t>«Явная модель запретов» РМ-1 задаёт, какие папки и файлы агенту трогать нельзя. Судьба содержимого разрешённых файлов на пути к LLM не описана. Четыре уточняющих вопроса вендору:</a:t>
-            </a:r>
-            <a:endParaRPr lang="en-US" sz="1350" dirty="0"/>
+              <a:t>«Явная модель запретов» РМ-1 задаёт, какие папки и файлы агенту трогать нельзя, но не описывает, что происходит с содержимым разрешённых файлов на пути к LLM. Наше сомнение в необходимости РМ-1 в текущем виде снимается или подтверждается четырьмя ответами вендора:</a:t>
+            </a:r>
+            <a:endParaRPr lang="en-US" sz="1250" dirty="0"/>
           </a:p>
         </p:txBody>
       </p:sp>
@@ -12676,12 +12688,12 @@
         </p:nvSpPr>
         <p:spPr>
           <a:xfrm>
-            <a:off x="548640" y="2212848"/>
-            <a:ext cx="5257800" cy="1691640"/>
+            <a:off x="548640" y="2331720"/>
+            <a:ext cx="5257800" cy="1627632"/>
           </a:xfrm>
           <a:prstGeom prst="roundRect">
             <a:avLst>
-              <a:gd name="adj" fmla="val 4865"/>
+              <a:gd name="adj" fmla="val 5056"/>
             </a:avLst>
           </a:prstGeom>
           <a:solidFill>
@@ -12710,7 +12722,7 @@
         </p:nvSpPr>
         <p:spPr>
           <a:xfrm>
-            <a:off x="804672" y="2450592"/>
+            <a:off x="804672" y="2569464"/>
             <a:ext cx="384048" cy="384048"/>
           </a:xfrm>
           <a:prstGeom prst="roundRect">
@@ -12732,7 +12744,7 @@
         </p:nvSpPr>
         <p:spPr>
           <a:xfrm>
-            <a:off x="850392" y="2450592"/>
+            <a:off x="850392" y="2569464"/>
             <a:ext cx="292608" cy="384048"/>
           </a:xfrm>
           <a:prstGeom prst="rect">
@@ -12771,7 +12783,7 @@
         </p:nvSpPr>
         <p:spPr>
           <a:xfrm>
-            <a:off x="5029200" y="2377440"/>
+            <a:off x="5029200" y="2496312"/>
             <a:ext cx="548640" cy="548640"/>
           </a:xfrm>
           <a:prstGeom prst="ellipse">
@@ -12799,7 +12811,7 @@
         </p:blipFill>
         <p:spPr>
           <a:xfrm>
-            <a:off x="5160874" y="2509114"/>
+            <a:off x="5160874" y="2627986"/>
             <a:ext cx="285293" cy="285293"/>
           </a:xfrm>
           <a:prstGeom prst="rect">
@@ -12815,7 +12827,7 @@
         </p:nvSpPr>
         <p:spPr>
           <a:xfrm>
-            <a:off x="1325880" y="2395728"/>
+            <a:off x="1325880" y="2514600"/>
             <a:ext cx="3886200" cy="365760"/>
           </a:xfrm>
           <a:prstGeom prst="rect">
@@ -12854,8 +12866,8 @@
         </p:nvSpPr>
         <p:spPr>
           <a:xfrm>
-            <a:off x="804672" y="2889504"/>
-            <a:ext cx="4745736" cy="868680"/>
+            <a:off x="804672" y="3008376"/>
+            <a:ext cx="4745736" cy="804672"/>
           </a:xfrm>
           <a:prstGeom prst="rect">
             <a:avLst/>
@@ -12896,12 +12908,12 @@
         </p:nvSpPr>
         <p:spPr>
           <a:xfrm>
-            <a:off x="6217920" y="2212848"/>
-            <a:ext cx="5257800" cy="1691640"/>
+            <a:off x="6217920" y="2331720"/>
+            <a:ext cx="5257800" cy="1627632"/>
           </a:xfrm>
           <a:prstGeom prst="roundRect">
             <a:avLst>
-              <a:gd name="adj" fmla="val 4865"/>
+              <a:gd name="adj" fmla="val 5056"/>
             </a:avLst>
           </a:prstGeom>
           <a:solidFill>
@@ -12930,7 +12942,7 @@
         </p:nvSpPr>
         <p:spPr>
           <a:xfrm>
-            <a:off x="6473952" y="2450592"/>
+            <a:off x="6473952" y="2569464"/>
             <a:ext cx="384048" cy="384048"/>
           </a:xfrm>
           <a:prstGeom prst="roundRect">
@@ -12952,7 +12964,7 @@
         </p:nvSpPr>
         <p:spPr>
           <a:xfrm>
-            <a:off x="6519672" y="2450592"/>
+            <a:off x="6519672" y="2569464"/>
             <a:ext cx="292608" cy="384048"/>
           </a:xfrm>
           <a:prstGeom prst="rect">
@@ -12991,7 +13003,7 @@
         </p:nvSpPr>
         <p:spPr>
           <a:xfrm>
-            <a:off x="10698480" y="2377440"/>
+            <a:off x="10698480" y="2496312"/>
             <a:ext cx="548640" cy="548640"/>
           </a:xfrm>
           <a:prstGeom prst="ellipse">
@@ -13019,7 +13031,7 @@
         </p:blipFill>
         <p:spPr>
           <a:xfrm>
-            <a:off x="10830154" y="2509114"/>
+            <a:off x="10830154" y="2627986"/>
             <a:ext cx="285293" cy="285293"/>
           </a:xfrm>
           <a:prstGeom prst="rect">
@@ -13035,7 +13047,7 @@
         </p:nvSpPr>
         <p:spPr>
           <a:xfrm>
-            <a:off x="6995160" y="2395728"/>
+            <a:off x="6995160" y="2514600"/>
             <a:ext cx="3886200" cy="365760"/>
           </a:xfrm>
           <a:prstGeom prst="rect">
@@ -13074,8 +13086,8 @@
         </p:nvSpPr>
         <p:spPr>
           <a:xfrm>
-            <a:off x="6473952" y="2889504"/>
-            <a:ext cx="4745736" cy="868680"/>
+            <a:off x="6473952" y="3008376"/>
+            <a:ext cx="4745736" cy="804672"/>
           </a:xfrm>
           <a:prstGeom prst="rect">
             <a:avLst/>
@@ -13116,12 +13128,12 @@
         </p:nvSpPr>
         <p:spPr>
           <a:xfrm>
-            <a:off x="548640" y="4133088"/>
-            <a:ext cx="5257800" cy="1691640"/>
+            <a:off x="548640" y="4187952"/>
+            <a:ext cx="5257800" cy="1627632"/>
           </a:xfrm>
           <a:prstGeom prst="roundRect">
             <a:avLst>
-              <a:gd name="adj" fmla="val 4865"/>
+              <a:gd name="adj" fmla="val 5056"/>
             </a:avLst>
           </a:prstGeom>
           <a:solidFill>
@@ -13150,7 +13162,7 @@
         </p:nvSpPr>
         <p:spPr>
           <a:xfrm>
-            <a:off x="804672" y="4370832"/>
+            <a:off x="804672" y="4425696"/>
             <a:ext cx="384048" cy="384048"/>
           </a:xfrm>
           <a:prstGeom prst="roundRect">
@@ -13172,7 +13184,7 @@
         </p:nvSpPr>
         <p:spPr>
           <a:xfrm>
-            <a:off x="850392" y="4370832"/>
+            <a:off x="850392" y="4425696"/>
             <a:ext cx="292608" cy="384048"/>
           </a:xfrm>
           <a:prstGeom prst="rect">
@@ -13211,7 +13223,7 @@
         </p:nvSpPr>
         <p:spPr>
           <a:xfrm>
-            <a:off x="5029200" y="4297680"/>
+            <a:off x="5029200" y="4352544"/>
             <a:ext cx="548640" cy="548640"/>
           </a:xfrm>
           <a:prstGeom prst="ellipse">
@@ -13239,7 +13251,7 @@
         </p:blipFill>
         <p:spPr>
           <a:xfrm>
-            <a:off x="5160874" y="4429354"/>
+            <a:off x="5160874" y="4484218"/>
             <a:ext cx="285293" cy="285293"/>
           </a:xfrm>
           <a:prstGeom prst="rect">
@@ -13255,7 +13267,7 @@
         </p:nvSpPr>
         <p:spPr>
           <a:xfrm>
-            <a:off x="1325880" y="4315968"/>
+            <a:off x="1325880" y="4370832"/>
             <a:ext cx="3886200" cy="365760"/>
           </a:xfrm>
           <a:prstGeom prst="rect">
@@ -13294,8 +13306,8 @@
         </p:nvSpPr>
         <p:spPr>
           <a:xfrm>
-            <a:off x="804672" y="4809744"/>
-            <a:ext cx="4745736" cy="868680"/>
+            <a:off x="804672" y="4864608"/>
+            <a:ext cx="4745736" cy="804672"/>
           </a:xfrm>
           <a:prstGeom prst="rect">
             <a:avLst/>
@@ -13336,12 +13348,12 @@
         </p:nvSpPr>
         <p:spPr>
           <a:xfrm>
-            <a:off x="6217920" y="4133088"/>
-            <a:ext cx="5257800" cy="1691640"/>
+            <a:off x="6217920" y="4187952"/>
+            <a:ext cx="5257800" cy="1627632"/>
           </a:xfrm>
           <a:prstGeom prst="roundRect">
             <a:avLst>
-              <a:gd name="adj" fmla="val 4865"/>
+              <a:gd name="adj" fmla="val 5056"/>
             </a:avLst>
           </a:prstGeom>
           <a:solidFill>
@@ -13370,7 +13382,7 @@
         </p:nvSpPr>
         <p:spPr>
           <a:xfrm>
-            <a:off x="6473952" y="4370832"/>
+            <a:off x="6473952" y="4425696"/>
             <a:ext cx="384048" cy="384048"/>
           </a:xfrm>
           <a:prstGeom prst="roundRect">
@@ -13392,7 +13404,7 @@
         </p:nvSpPr>
         <p:spPr>
           <a:xfrm>
-            <a:off x="6519672" y="4370832"/>
+            <a:off x="6519672" y="4425696"/>
             <a:ext cx="292608" cy="384048"/>
           </a:xfrm>
           <a:prstGeom prst="rect">
@@ -13431,7 +13443,7 @@
         </p:nvSpPr>
         <p:spPr>
           <a:xfrm>
-            <a:off x="10698480" y="4297680"/>
+            <a:off x="10698480" y="4352544"/>
             <a:ext cx="548640" cy="548640"/>
           </a:xfrm>
           <a:prstGeom prst="ellipse">
@@ -13459,7 +13471,7 @@
         </p:blipFill>
         <p:spPr>
           <a:xfrm>
-            <a:off x="10830154" y="4429354"/>
+            <a:off x="10830154" y="4484218"/>
             <a:ext cx="285293" cy="285293"/>
           </a:xfrm>
           <a:prstGeom prst="rect">
@@ -13475,7 +13487,7 @@
         </p:nvSpPr>
         <p:spPr>
           <a:xfrm>
-            <a:off x="6995160" y="4315968"/>
+            <a:off x="6995160" y="4370832"/>
             <a:ext cx="3886200" cy="365760"/>
           </a:xfrm>
           <a:prstGeom prst="rect">
@@ -13514,8 +13526,8 @@
         </p:nvSpPr>
         <p:spPr>
           <a:xfrm>
-            <a:off x="6473952" y="4809744"/>
-            <a:ext cx="4745736" cy="868680"/>
+            <a:off x="6473952" y="4864608"/>
+            <a:ext cx="4745736" cy="804672"/>
           </a:xfrm>
           <a:prstGeom prst="rect">
             <a:avLst/>
@@ -13691,7 +13703,7 @@
                 <a:ea typeface="Calibri" pitchFamily="34" charset="-122"/>
                 <a:cs typeface="Calibri" pitchFamily="34" charset="-120"/>
               </a:rPr>
-              <a:t>ЧАСТЬ 1 · ПОЧЕМУ ЭТО ВАЖНО</a:t>
+              <a:t>ЧАСТЬ 1 · ПОЧЕМУ ОСТАЮТСЯ СОМНЕНИЯ</a:t>
             </a:r>
             <a:endParaRPr lang="en-US" sz="1150" dirty="0"/>
           </a:p>
@@ -13725,7 +13737,7 @@
               <a:buNone/>
             </a:pPr>
             <a:r>
-              <a:rPr lang="en-US" sz="2900" b="1" dirty="0">
+              <a:rPr lang="en-US" sz="2700" b="1" dirty="0">
                 <a:solidFill>
                   <a:srgbClr val="1B1E27"/>
                 </a:solidFill>
@@ -13733,9 +13745,9 @@
                 <a:ea typeface="Cambria" pitchFamily="34" charset="-122"/>
                 <a:cs typeface="Cambria" pitchFamily="34" charset="-120"/>
               </a:rPr>
-              <a:t>Единственный пункт всей дорожной карты с явным потенциальным пробелом в безопасности</a:t>
-            </a:r>
-            <a:endParaRPr lang="en-US" sz="2900" dirty="0"/>
+              <a:t>Единственный пункт дорожной карты, где защита данных пока не описана</a:t>
+            </a:r>
+            <a:endParaRPr lang="en-US" sz="2700" dirty="0"/>
           </a:p>
         </p:txBody>
       </p:sp>
@@ -13843,7 +13855,7 @@
                 <a:ea typeface="Calibri" pitchFamily="34" charset="-122"/>
                 <a:cs typeface="Calibri" pitchFamily="34" charset="-120"/>
               </a:rPr>
-              <a:t>пунктов дорожной карты — с очевидным потенциальным пробелом в защите данных</a:t>
+              <a:t>пунктов дорожной карты — с пока не описанной защитой данных</a:t>
             </a:r>
             <a:endParaRPr lang="en-US" sz="1300" dirty="0"/>
           </a:p>
@@ -13858,7 +13870,7 @@
         <p:spPr>
           <a:xfrm>
             <a:off x="4297680" y="1691640"/>
-            <a:ext cx="7345375" cy="914400"/>
+            <a:ext cx="7345375" cy="1051560"/>
           </a:xfrm>
           <a:prstGeom prst="rect">
             <a:avLst/>
@@ -13872,12 +13884,12 @@
           <a:p>
             <a:pPr indent="0" marL="0">
               <a:lnSpc>
-                <a:spcPct val="128000"/>
+                <a:spcPct val="126000"/>
               </a:lnSpc>
               <a:buNone/>
             </a:pPr>
             <a:r>
-              <a:rPr lang="en-US" sz="1350" dirty="0">
+              <a:rPr lang="en-US" sz="1250" dirty="0">
                 <a:solidFill>
                   <a:srgbClr val="1B1E27"/>
                 </a:solidFill>
@@ -13885,9 +13897,9 @@
                 <a:ea typeface="Calibri" pitchFamily="34" charset="-122"/>
                 <a:cs typeface="Calibri" pitchFamily="34" charset="-120"/>
               </a:rPr>
-              <a:t>Если маскирование не гарантировано архитектурно для локально читаемых файлов, агент рабочей станции становится новым каналом утечки — в обход периметра AI Guard, выстроенного для серверной части.</a:t>
-            </a:r>
-            <a:endParaRPr lang="en-US" sz="1350" dirty="0"/>
+              <a:t>Если маскирование архитектурно не распространяется на локально читаемые файлы, агент рабочей станции рискует стать новым каналом в обход периметра AI Guard, выстроенного для серверной части. Это и есть та неопределённость, из-за которой у нас остаются сомнения в необходимости РМ-1 в текущем виде.</a:t>
+            </a:r>
+            <a:endParaRPr lang="en-US" sz="1250" dirty="0"/>
           </a:p>
         </p:txBody>
       </p:sp>
@@ -14147,12 +14159,12 @@
           <a:p>
             <a:pPr indent="0" marL="0">
               <a:lnSpc>
-                <a:spcPct val="125000"/>
+                <a:spcPct val="122000"/>
               </a:lnSpc>
               <a:buNone/>
             </a:pPr>
             <a:r>
-              <a:rPr lang="en-US" sz="1250" i="1" dirty="0">
+              <a:rPr lang="en-US" sz="1200" i="1" dirty="0">
                 <a:solidFill>
                   <a:srgbClr val="5B6472"/>
                 </a:solidFill>
@@ -14160,9 +14172,9 @@
                 <a:ea typeface="Calibri" pitchFamily="34" charset="-122"/>
                 <a:cs typeface="Calibri" pitchFamily="34" charset="-120"/>
               </a:rPr>
-              <a:t>Статус: вопрос сформулирован в case-11 и ждёт ответа вендора. Уровень C у РМ-1/РМ-2 означает подтверждённое направление, но не обязательство по срокам — задать вопрос стоит до того, как оба пункта закрепятся в договоре, а не после.</a:t>
-            </a:r>
-            <a:endParaRPr lang="en-US" sz="1250" dirty="0"/>
+              <a:t>Статус: это не рекомендация отказаться от РМ-1 — необходимость этого расширения в заявленном виде для нас пока не доказана, и ответы вендора на предыдущем слайде её снимут или подтвердят. Уровень C означает подтверждённое направление, но не обязательство по срокам — самое время спросить, пока пункт не закрепился в договоре.</a:t>
+            </a:r>
+            <a:endParaRPr lang="en-US" sz="1200" dirty="0"/>
           </a:p>
         </p:txBody>
       </p:sp>
@@ -14413,7 +14425,7 @@
                 <a:ea typeface="Calibri" pitchFamily="34" charset="-122"/>
                 <a:cs typeface="Calibri" pitchFamily="34" charset="-120"/>
               </a:rPr>
-              <a:t>Гранулярный доступ к документам — предложение для дорожной карты, не найденный дефект</a:t>
+              <a:t>Гранулярный доступ к документам — готовое предложение к реализации, а не открытый вопрос без ответа</a:t>
             </a:r>
             <a:endParaRPr lang="en-US" sz="1500" dirty="0"/>
           </a:p>
@@ -15476,7 +15488,7 @@
                 <a:ea typeface="Calibri" pitchFamily="34" charset="-122"/>
                 <a:cs typeface="Calibri" pitchFamily="34" charset="-120"/>
               </a:rPr>
-              <a:t>ЧАСТЬ 2 · ГДЕ НЕ ХВАТАЕТ</a:t>
+              <a:t>ЧАСТЬ 2 · ГДЕ НУЖНО РЕШЕНИЕ</a:t>
             </a:r>
             <a:endParaRPr lang="en-US" sz="1150" dirty="0"/>
           </a:p>

</xml_diff>

<commit_message>
Reframe case-17 deck voice: analyst addressing developer, not vendor
Replaced "вендор" as addressee throughout visible slide text and
speaker notes with "разработчик" ("разработчику"/"с разработчиком"),
and shifted the framing device from an institutional client-to-vendor
document handoff to a first-person analyst's direct outreach to the
platform's development team. Kept both established Part 1/Part 2
theses and the 4 vendor-question texts on slide 5 verbatim.

Co-Authored-By: Claude Sonnet 5 <noreply@anthropic.com>
Claude-Session: https://claude.ai/code/session_01DpSN8JwCJ3tg3JVUadr2zE
</commit_message>
<xml_diff>
--- a/docs/presentations/case-17-lokalny-chat-i-ierarhiya-katalogov.pptx
+++ b/docs/presentations/case-17-lokalny-chat-i-ierarhiya-katalogov.pptx
@@ -519,7 +519,7 @@
           <a:p>
             <a:r>
               <a:rPr lang="en-US" dirty="0"/>
-              <a:t>Титульный слайд. Обе темы этой колоды — не готовые функции платформы, а вопросы и предложения, которые команда планирует поднять на ближайшем разговоре с вендором «Камераты» по дорожной карте. Полный текст обоих вопросов уже зафиксирован в docs/analysis/case-11-voprosy-vendoru-roadmap.md — эта колода делает их презентационно понятными коллеге, который не читал исходники.</a:t>
+              <a:t>Титульный слайд. Обе темы этой колоды — не готовые функции платформы, а находки и предложения, которые я как аналитик планирую поднять на ближайшем разговоре с разработчиком «Камераты» по дорожной карте. Полный текст обоих вопросов уже зафиксирован во внутренних материалах для разработчика — эта колода делает их презентационно понятными коллеге, который не читал исходники.</a:t>
             </a:r>
             <a:endParaRPr lang="en-US" dirty="0"/>
           </a:p>
@@ -607,7 +607,7 @@
           <a:p>
             <a:r>
               <a:rPr lang="en-US" dirty="0"/>
-              <a:t>Самая важная диаграмма всей колоды, обновлена после переименования примера (см. слайд-заметки о коллизии с зарезервированными именами доменов платформы «Логистика»/«Персонал»/«Продажи» — kamerata-overview-review.md, строки 118/452/968 — новый пример использует «Отдел маркетинга», «Юридический отдел», «Бухгалтерия»). Домен «Кадры» — корень. Три независимые ветки первого уровня: «Общее» (видна персоне «Сотрудник», делится на «Больничные»/«Отпускные»), «Оклады» (делится по отделам — маркетинг, юротдел, бухгалтерия) и «Личные дела» (третья, отдельная ветка — не потомок ни «Общее», ни «Оклады» — с ещё более узким подузлом «Топ-менеджмент», демонстрирующим, что дерево не ограничено двумя уровнями). Директор по персоналу привязан к корню и наследует всё дерево — это не частная удобная деталь примера, а закреплённый во всех проверенных аналогах инвариант корня (case-19, §4.3: в Purview права default-домена в принципе нельзя ограничить).</a:t>
+              <a:t>Самая важная диаграмма всей колоды, обновлена после переименования примера (коллизия с зарезервированными именами доменов платформы «Логистика»/«Персонал»/«Продажи», уже встречающимися в документации платформы как примеры доменов, — новый пример использует «Отдел маркетинга», «Юридический отдел», «Бухгалтерия»). Домен «Кадры» — корень. Три независимые ветки первого уровня: «Общее» (видна персоне «Сотрудник», делится на «Больничные»/«Отпускные»), «Оклады» (делится по отделам — маркетинг, юротдел, бухгалтерия) и «Личные дела» (третья, отдельная ветка — не потомок ни «Общее», ни «Оклады» — с ещё более узким подузлом «Топ-менеджмент», демонстрирующим, что дерево не ограничено двумя уровнями). Директор по персоналу привязан к корню и наследует всё дерево — это не частная удобная деталь примера, а закреплённый во всех проверенных индустриальных аналогах инвариант корня (в Microsoft Purview права default-домена в принципе нельзя ограничить).</a:t>
             </a:r>
             <a:endParaRPr lang="en-US" dirty="0"/>
           </a:p>
@@ -695,7 +695,7 @@
           <a:p>
             <a:r>
               <a:rPr lang="en-US" dirty="0"/>
-              <a:t>Новый слайд — прямой ответ на замечание пользователя после просмотра дерева: каталог может по смыслу принадлежать больше чем одному домену. Точная формулировка, которую важно не смазать: это НЕ исключение из правила «видимость течёт только вниз» — правило продолжает действовать независимо и полностью внутри каждого домена (персона на корне «Кадры» видит «Список сотрудников» по обычному нисходящему наследованию, точно так же персона в «Продажи»). Новое — только то, что один и тот же узел может быть нисходяще достижимым сразу в двух разных деревьях одновременно, то есть иметь двух родителей, а не одного. Это зеркальный случай вопросу 4 из case-11 (там — доступ персоны к нескольким несмежным узлам ОДНОГО домена; здесь — членство каталога сразу в НЕСКОЛЬКИХ доменах) и прямая иллюстрация вывода case-19 §5: ни одна из проверенных зрелых систем (SharePoint, Google Drive, Purview, Databricks) не обошлась без отдельного механизма для похожего кросс-веточного/кросс-доменного случая. Это не повод сомневаться в самом предложении дерева — это конкретная реализационная деталь, которую честнее поднять сейчас и решить вместе с вендором, чем сделать вид, что её не существует.</a:t>
+              <a:t>Новый слайд — прямой ответ на замечание пользователя после просмотра дерева: каталог может по смыслу принадлежать больше чем одному домену. Точная формулировка, которую важно не смазать: это НЕ исключение из правила «видимость течёт только вниз» — правило продолжает действовать независимо и полностью внутри каждого домена (персона на корне «Кадры» видит «Список сотрудников» по обычному нисходящему наследованию, точно так же персона в «Продажи»). Новое — только то, что один и тот же узел может быть нисходяще достижимым сразу в двух разных деревьях одновременно, то есть иметь двух родителей, а не одного. Это зеркальный случай моему вопросу к разработчику о доступе персоны к нескольким несмежным узлам ОДНОГО домена — здесь, наоборот, членство каталога сразу в НЕСКОЛЬКИХ доменах — и прямая иллюстрация вывода моего исследования прецедентов: ни одна из проверенных зрелых систем (SharePoint, Google Drive, Purview, Databricks) не обошлась без отдельного механизма для похожего кросс-веточного/кросс-доменного случая. Это не повод сомневаться в самом предложении дерева — это конкретная реализационная деталь, которую честнее поднять сейчас и решить вместе с разработчиком, чем сделать вид, что её не существует.</a:t>
             </a:r>
             <a:endParaRPr lang="en-US" dirty="0"/>
           </a:p>
@@ -783,7 +783,7 @@
           <a:p>
             <a:r>
               <a:rPr lang="en-US" dirty="0"/>
-              <a:t>Формулировка правила дословно из case-11: «видимость течёт вниз по дереву от узла привязки, вбок и вверх — не течёт». Схема показывает все три направления сразу: вниз (потомки) — разрешено сплошной зелёной линией, вверх (предки) и вбок (соседние ветки) — запрещено, показано пунктирной красной линией. Это правило целиком заменяет собой сегодняшнюю бинарную модель «у коллекции есть домен / домена нет».</a:t>
+              <a:t>Формулировка правила дословно из моего предложения разработчику: «видимость течёт вниз по дереву от узла привязки, вбок и вверх — не течёт». Схема показывает все три направления сразу: вниз (потомки) — разрешено сплошной зелёной линией, вверх (предки) и вбок (соседние ветки) — запрещено, показано пунктирной красной линией. Это правило целиком заменяет собой сегодняшнюю бинарную модель «у коллекции есть домен / домена нет».</a:t>
             </a:r>
             <a:endParaRPr lang="en-US" dirty="0"/>
           </a:p>
@@ -871,7 +871,7 @@
           <a:p>
             <a:r>
               <a:rPr lang="en-US" dirty="0"/>
-              <a:t>Три строки — три персоны на переименованном дереве «Кадры» (переименовано после коллизии с зарезервированными платформенными именами доменов «Логистика»/«Персонал»/«Продажи», см. заметки к слайду с деревом). Средняя строка — исправленный после критики case-20 составной пример: «Начальник отдела маркетинга» — не единственная персона, привязанная к одному узлу, а явная множественная привязка сразу к двум узлам («Общее» и «Оклады/Отдел маркетинга»). Это прямое продолжение того, как многодоменность уже работает сегодня без всякого дерева («выбрать домен(ы) из списка» — множественное число, instrukciya-domeny-i-dostup.md), а не костыль поверх дерева. Директор по персоналу — на корне, поэтому видит всё дерево автоматически; это задокументированный во всех проверенных аналогах инвариант корня (case-19, §4.3), а не удобная деталь примера.</a:t>
+              <a:t>Три строки — три персоны на переименованном дереве «Кадры» (переименовано после коллизии с зарезервированными платформенными именами доменов «Логистика»/«Персонал»/«Продажи», см. заметки к слайду с деревом). Средняя строка — исправленный после внутренней критики составной пример: «Начальник отдела маркетинга» — не единственная персона, привязанная к одному узлу, а явная множественная привязка сразу к двум узлам («Общее» и «Оклады/Отдел маркетинга»). Это прямое продолжение того, как многодоменность уже работает сегодня без всякого дерева (в рабочей инструкции платформы — «выбрать домен(ы) из списка», множественное число), а не костыль поверх дерева. Директор по персоналу — на корне, поэтому видит всё дерево автоматически; это задокументированный во всех проверенных индустриальных аналогах инвариант корня, а не удобная деталь примера.</a:t>
             </a:r>
             <a:endParaRPr lang="en-US" dirty="0"/>
           </a:p>
@@ -959,7 +959,7 @@
           <a:p>
             <a:r>
               <a:rPr lang="en-US" dirty="0"/>
-              <a:t>Обновлено по итогам case-19/case-20: раньше средний пункт был непроверенным утверждением «давно стандартно в DMS/DAM-системах» без единого названного продукта (справедливо раскритиковано в case-20, §3). Теперь — конкретные, названные прецеденты из case-19: Microsoft Purview (самый близкий — есть буквально функция «Restrict inherited permissions» и тот же инвариант «корень нельзя ограничить»), Google Drive («Limited access»/«Expansive access»), SharePoint («break inheritance»), Databricks Unity Catalog (наследование по catalog.schema.table). Первый пункт также уточнён: предложение решает 2b (организация доменов), а не 2a (гранулярность внутри документа) — это два разных вопроса вендору, разница объяснена на предыдущем слайде. Это опора для уверенного тона части 2: мы предлагаем не гипотезу, а модель, чьё поведение по умолчанию уже проверено в нескольких независимо развивавшихся системах.</a:t>
+              <a:t>Обновлено по итогам внутренней критики и исследования прецедентов: раньше средний пункт был непроверенным утверждением «давно стандартно в DMS/DAM-системах» без единого названного продукта (справедливо раскритиковано внутри команды). Теперь — конкретные, названные прецеденты: Microsoft Purview (самый близкий — есть буквально функция «Restrict inherited permissions» и тот же инвариант «корень нельзя ограничить»), Google Drive («Limited access»/«Expansive access»), SharePoint («break inheritance»), Databricks Unity Catalog (наследование по catalog.schema.table). Первый пункт также уточнён: предложение решает 2b (организация доменов), а не 2a (гранулярность внутри документа) — это два разных вопроса к разработчику, разница объяснена на предыдущем слайде. Это опора для уверенного тона части 2: я предлагаю разработчику не гипотезу, а модель, чьё поведение по умолчанию уже проверено в нескольких независимо развивавшихся системах.</a:t>
             </a:r>
             <a:endParaRPr lang="en-US" dirty="0"/>
           </a:p>
@@ -1135,7 +1135,7 @@
           <a:p>
             <a:r>
               <a:rPr lang="en-US" dirty="0"/>
-              <a:t>Формулировка статуса намеренная и увереннее, чем раньше: это готовое предложение к реализации, поданное вендору как модель, которую мы предлагаем включить в дорожную карту, а не жалоба на текущую функциональность и не гипотеза для обсуждения «стоит ли вообще». Открытые детали (двойное членство каталогов, реструктуризация дерева, множественная привязка персон) остаются реальными и честно названы на предыдущих слайдах — но как то, что дорабатывается вместе с вендором в процессе реализации, а не как причины сомневаться в самом предложении. В case-11 пункт явно не привязан к конкретному коду роадмапа — предполагаем линию «Каталог» (КАТ-) или «Надзор» (НАД-) как наиболее вероятных кандидатов.</a:t>
+              <a:t>Формулировка статуса намеренная и увереннее, чем раньше: это готовое предложение к реализации, которое я как аналитик приношу разработчику как модель, предлагаемую в дорожную карту, а не жалоба на текущую функциональность и не гипотеза для обсуждения «стоит ли вообще». Открытые детали (двойное членство каталогов, реструктуризация дерева, множественная привязка персон) остаются реальными и честно названы на предыдущих слайдах — но как то, что дорабатывается вместе с разработчиком в процессе реализации, а не как причины сомневаться в самом предложении. Пункт явно не привязан к конкретному коду роадмапа — предполагаю линию «Каталог» (КАТ-) или «Надзор» (НАД-) как наиболее вероятных кандидатов.</a:t>
             </a:r>
             <a:endParaRPr lang="en-US" dirty="0"/>
           </a:p>
@@ -1223,7 +1223,7 @@
           <a:p>
             <a:r>
               <a:rPr lang="en-US" dirty="0"/>
-              <a:t>Слайд-синтез, связывающий обе части и явно называющий две разные позиции по ним: и локальный чат, и иерархия каталогов — про одну и ту же границу между тем, что платформа уже гарантирует документированно, и тем, что нужно решить по мере роста поверхности платформы. Но решаются они по-разному: Часть 1 (новое место исполнения) — это открытый вопрос вендору, наше сомнение в необходимости; Часть 2 (более тонкая гранулярность доступа) — это наше предложение к реализации, которое мы считаем готовым. Оба поднимаются заранее, пока ни один не стал контрактным обязательством.</a:t>
+              <a:t>Слайд-синтез, связывающий обе части и явно называющий две разные позиции по ним: и локальный чат, и иерархия каталогов — про одну и ту же границу между тем, что платформа уже гарантирует документированно, и тем, что нужно решить по мере роста поверхности платформы. Но решаются они по-разному: Часть 1 (новое место исполнения) — это открытый вопрос к разработчику, моё сомнение в необходимости; Часть 2 (более тонкая гранулярность доступа) — это моё предложение к реализации, которое я считаю готовым. Оба поднимаются заранее, пока ни один не стал контрактным обязательством.</a:t>
             </a:r>
             <a:endParaRPr lang="en-US" dirty="0"/>
           </a:p>
@@ -1311,7 +1311,7 @@
           <a:p>
             <a:r>
               <a:rPr lang="en-US" dirty="0"/>
-              <a:t>Закрывающий слайд, явно фиксирующий две разные позиции колоды: Часть 1 — открытый вопрос вендору о необходимости РМ-1 в заявленном виде, ответа пока нет; Часть 2 — наше предложение к реализации, которое мы считаем проработанным и готовы обсуждать детали. Единственный источник фактов для обеих тем — case-11-voprosy-vendoru-roadmap.md; он же станет местом, куда будут добавлены ответы вендора по мере их получения, и куда попадут следующие вопросы по дорожной карте по мере разбора остальных пунктов.</a:t>
+              <a:t>Закрывающий слайд, явно фиксирующий две разные позиции колоды: Часть 1 — открытый вопрос к разработчику о необходимости РМ-1 в заявленном виде, ответа пока нет; Часть 2 — моё предложение к реализации, которое я считаю проработанным и готов обсуждать детали. Единственный источник фактов для обеих тем — материалы, которые я как аналитик подготовил для разговора с разработчиком; они же станут местом, куда будут добавлены его ответы по мере их получения, и куда попадут следующие вопросы по дорожной карте по мере разбора остальных пунктов.</a:t>
             </a:r>
             <a:endParaRPr lang="en-US" dirty="0"/>
           </a:p>
@@ -1399,7 +1399,7 @@
           <a:p>
             <a:r>
               <a:rPr lang="en-US" dirty="0"/>
-              <a:t>Смысл слайда — сразу задать две разные позиции по двум темам, а не подавать обе как одинаково открытые вопросы. Часть 1 (локальный чат / агент рабочей станции, РМ-1): у нас есть сомнения, нужно ли это расширение в заявленном виде, пока не решён вопрос о защите данных на компьютере сотрудника — это диалог с вендором, а не отказ от функции. Часть 2 (иерархия каталогов): у нас есть проработанная модель (дерево каталогов), которую мы считаем достаточно зрелой, чтобы предлагать её в дорожную карту и обсуждать детали реализации, а не решать, стоит ли вообще что-то делать. Оба уже зафиксированы в пакете вопросов вендору (case-11).</a:t>
+              <a:t>Смысл слайда — сразу задать две разные позиции по двум темам, а не подавать обе как одинаково открытые вопросы. Часть 1 (локальный чат / агент рабочей станции, РМ-1): у меня как у аналитика есть сомнения, нужно ли это расширение в заявленном виде, пока не решён вопрос о защите данных на компьютере сотрудника — это диалог с разработчиком, а не отказ от функции. Часть 2 (иерархия каталогов): есть проработанная модель (дерево каталогов), которую я считаю достаточно зрелой, чтобы предлагать её в дорожную карту и обсуждать детали реализации с разработчиком, а не решать, стоит ли вообще что-то делать. Обе темы уже оформлены в материалах, которые я готовил для этого разговора с разработчиком.</a:t>
             </a:r>
             <a:endParaRPr lang="en-US" dirty="0"/>
           </a:p>
@@ -1487,7 +1487,7 @@
           <a:p>
             <a:r>
               <a:rPr lang="en-US" dirty="0"/>
-              <a:t>Раздел-разделитель. Дальше — три плотных слайда о линии «Раб. места» дорожной карты (сознательно сокращено с восьми — часть 1 не должна разворачиваться дольше, чем нужно для передачи технического запроса): что это и какие четыре пункта в неё входят, четыре вопроса вендору, ответы на которые снимут или подтвердят сомнение, и почему сомнение вообще возникло — с закрывающим статусом. Тон намеренно мягкий: это не рекомендация отказаться от РМ-1, а вопрос, который вендор может закрыть ответом.</a:t>
+              <a:t>Раздел-разделитель. Дальше — три плотных слайда о линии «Раб. места» дорожной карты (сознательно сокращено с восьми — часть 1 не должна разворачиваться дольше, чем нужно для передачи технического запроса): что это и какие четыре пункта в неё входят, четыре вопроса к разработчику, ответы на которые снимут или подтвердят сомнение, и почему сомнение вообще возникло — с закрывающим статусом. Тон намеренно мягкий: это не рекомендация отказаться от РМ-1, а вопрос, который разработчик может закрыть ответом.</a:t>
             </a:r>
             <a:endParaRPr lang="en-US" dirty="0"/>
           </a:p>
@@ -1663,7 +1663,7 @@
           <a:p>
             <a:r>
               <a:rPr lang="en-US" dirty="0"/>
-              <a:t>Все четыре формулировки — дословно из Вопроса 1 в case-11-voprosy-vendoru-roadmap.md, содержание не сокращалось и не смягчалось. Порядок сохранён: (1) применяется ли то же маскирование, (2) действует ли то же правило про внешние/облачные модели, (3) кто задаёт запреты — админ или сам пользователь, (4) единый ли журнал аудита. Это основной содержательный слайд части 1: раньше подавался как «уточняющие вопросы к уже принятому пункту», теперь — как условия, при выполнении которых наше сомнение в необходимости РМ-1 снимается. Вокруг него специально убраны декоративные слайды-подводки.</a:t>
+              <a:t>Все четыре формулировки — дословно из вопроса, который я готовлю к разработчику, содержание не сокращалось и не смягчалось. Порядок сохранён: (1) применяется ли то же маскирование, (2) действует ли то же правило про внешние/облачные модели, (3) кто задаёт запреты — админ или сам пользователь, (4) единый ли журнал аудита. Это основной содержательный слайд части 1: раньше подавался как «уточняющие вопросы к уже принятому пункту», теперь — как условия, при выполнении которых моё сомнение в необходимости РМ-1 снимается. Вокруг него специально убраны декоративные слайды-подводки.</a:t>
             </a:r>
             <a:endParaRPr lang="en-US" dirty="0"/>
           </a:p>
@@ -1751,7 +1751,7 @@
           <a:p>
             <a:r>
               <a:rPr lang="en-US" dirty="0"/>
-              <a:t>Это наша внутренняя оценка (не для передачи вендору как есть, только для собственной подготовки) — из всех 35 пунктов дорожной карты это единственный, где рядом с новой функцией явно не упомянута уже заявленная модель защиты данных, и это главная опора нашего сомнения в необходимости РМ-1 в текущем виде. Слайд объединяет аргумент «почему сомнение возникло» с закрывающим статусом части 1 — отдельного слайда-итога больше нет, статус дан одной строкой внизу: это открытый вопрос вендору, а не рекомендация отказаться от пункта; уровень C — не обязательство по срокам, так что сейчас подходящий момент спросить.</a:t>
+              <a:t>Это моя внутренняя оценка как аналитика (не для передачи разработчику как есть, только для собственной подготовки к разговору) — из всех 35 пунктов дорожной карты это единственный, где рядом с новой функцией явно не упомянута уже заявленная модель защиты данных, и это главная опора моего сомнения в необходимости РМ-1 в текущем виде. Слайд объединяет аргумент «почему сомнение возникло» с закрывающим статусом части 1 — отдельного слайда-итога больше нет, статус дан одной строкой внизу: это открытый вопрос к разработчику, а не рекомендация отказаться от пункта; уровень C — не обязательство по срокам, так что сейчас подходящий момент спросить.</a:t>
             </a:r>
             <a:endParaRPr lang="en-US" dirty="0"/>
           </a:p>
@@ -1839,7 +1839,7 @@
           <a:p>
             <a:r>
               <a:rPr lang="en-US" dirty="0"/>
-              <a:t>Раздел-разделитель. Дальше — десять слайдов: сегодняшняя плоская модель доменов/коллекций, где она упирается в реальный сценарий (с явным разделением на два разных вопроса — 2a и 2b, по пересмотру case-11/case-20), дерево каталогов как готовое предложение по 2b с ключевой диаграммой, отдельный слайд про кросс-доменное пересечение коллекций (деталь, которую доработаем вместе с вендором при реализации), правило наследования, три персоны на новом дереве, почему предложение реалистично — с прецедентами из case-19, и что остаётся в силе, пока идём к реализации. Тон части 2 — увереннее, чем части 1: это не вопрос «стоит ли», а предложение «вот модель, готовы прорабатывать детали».</a:t>
+              <a:t>Раздел-разделитель. Дальше — десять слайдов: сегодняшняя плоская модель доменов/коллекций, где она упирается в реальный сценарий (с явным разделением на два разных вопроса — 2a и 2b, по итогам внутреннего пересмотра), дерево каталогов как готовое предложение по 2b с ключевой диаграммой, отдельный слайд про кросс-доменное пересечение коллекций (деталь, которую доработаем вместе с разработчиком при реализации), правило наследования, три персоны на новом дереве, почему предложение реалистично — с прецедентами из индустрии, и что остаётся в силе, пока идём к реализации. Тон части 2 — увереннее, чем части 1: это не вопрос «стоит ли», а предложение «вот модель, готов прорабатывать детали с разработчиком».</a:t>
             </a:r>
             <a:endParaRPr lang="en-US" dirty="0"/>
           </a:p>
@@ -2015,7 +2015,7 @@
           <a:p>
             <a:r>
               <a:rPr lang="en-US" dirty="0"/>
-              <a:t>Прямое сопоставление: RLS уже решает задачу «разная аудитория внутри одной сущности» для таблиц. Для документов эквивалента нет — единственный путь сегодня: дробление на новые коллекции/домены. Важное уточнение после независимой критики (case-20) и исследования прецедентов (case-19): это на самом деле два разных вопроса, которые легко перепутать — 2a (гранулярность внутри одной коллекции, до уровня документа/раздела/тега — предложение дерева её НЕ решает, потому что домен по документированной сегодня архитектуре — неизменяемое после создания поле коллекции, значит любой узел дерева технически реализуем только как отдельная коллекция) и 2b (организация множества плоских доменов в управляемую иерархию — вот что дерево действительно даёт). Раньше колода не разделяла их явно — это исправлено по итогам пересмотра case-11.</a:t>
+              <a:t>Прямое сопоставление: RLS уже решает задачу «разная аудитория внутри одной сущности» для таблиц. Для документов эквивалента нет — единственный путь сегодня: дробление на новые коллекции/домены. Важное уточнение после независимой внутренней критики и исследования прецедентов: это на самом деле два разных вопроса, которые легко перепутать — 2a (гранулярность внутри одной коллекции, до уровня документа/раздела/тега — предложение дерева её НЕ решает, потому что домен по документированной сегодня архитектуре — неизменяемое после создания поле коллекции, значит любой узел дерева технически реализуем только как отдельная коллекция) и 2b (организация множества плоских доменов в управляемую иерархию — вот что дерево действительно даёт). Раньше колода не разделяла их явно — это исправлено по итогам внутреннего пересмотра.</a:t>
             </a:r>
             <a:endParaRPr lang="en-US" dirty="0"/>
           </a:p>
@@ -2436,7 +2436,7 @@
         <p:spPr>
           <a:xfrm>
             <a:off x="548640" y="1691640"/>
-            <a:ext cx="8229600" cy="1691640"/>
+            <a:ext cx="8229600" cy="1005840"/>
           </a:xfrm>
           <a:prstGeom prst="rect">
             <a:avLst/>
@@ -2455,7 +2455,7 @@
               <a:buNone/>
             </a:pPr>
             <a:r>
-              <a:rPr lang="en-US" sz="3400" b="1" dirty="0">
+              <a:rPr lang="en-US" sz="2700" b="1" dirty="0">
                 <a:solidFill>
                   <a:srgbClr val="FFFFFF"/>
                 </a:solidFill>
@@ -2465,7 +2465,7 @@
               </a:rPr>
               <a:t>Два направления к дорожной карте:</a:t>
             </a:r>
-            <a:endParaRPr lang="en-US" sz="3400" dirty="0"/>
+            <a:endParaRPr lang="en-US" sz="2700" dirty="0"/>
           </a:p>
           <a:p>
             <a:pPr indent="0" marL="0">
@@ -2475,7 +2475,7 @@
               <a:buNone/>
             </a:pPr>
             <a:r>
-              <a:rPr lang="en-US" sz="3400" b="1" dirty="0">
+              <a:rPr lang="en-US" sz="2700" b="1" dirty="0">
                 <a:solidFill>
                   <a:srgbClr val="FFFFFF"/>
                 </a:solidFill>
@@ -2485,7 +2485,7 @@
               </a:rPr>
               <a:t>локальный чат и иерархия каталогов</a:t>
             </a:r>
-            <a:endParaRPr lang="en-US" sz="3400" dirty="0"/>
+            <a:endParaRPr lang="en-US" sz="2700" dirty="0"/>
           </a:p>
         </p:txBody>
       </p:sp>
@@ -2497,8 +2497,8 @@
         </p:nvSpPr>
         <p:spPr>
           <a:xfrm>
-            <a:off x="548640" y="3566160"/>
-            <a:ext cx="7315200" cy="1005840"/>
+            <a:off x="548640" y="2880360"/>
+            <a:ext cx="7315200" cy="1371600"/>
           </a:xfrm>
           <a:prstGeom prst="rect">
             <a:avLst/>
@@ -2525,7 +2525,7 @@
                 <a:ea typeface="Calibri" pitchFamily="34" charset="-122"/>
                 <a:cs typeface="Calibri" pitchFamily="34" charset="-120"/>
               </a:rPr>
-              <a:t>Два предложения и вопроса к команде платформы — направления, которые ещё не стали функциями и не зафиксированы в договоре, а обсуждаются на ближайшем roadmap-разговоре.</a:t>
+              <a:t>Как аналитик, внимательно изучивший обе темы, поднимаю их с разработчиком платформы — направления, которые ещё не стали функциями и не зафиксированы в договоре, а обсуждаются на ближайшем roadmap-разговоре.</a:t>
             </a:r>
             <a:endParaRPr lang="en-US" sz="1550" dirty="0"/>
           </a:p>
@@ -2898,7 +2898,7 @@
                 <a:ea typeface="Calibri" pitchFamily="34" charset="-122"/>
                 <a:cs typeface="Calibri" pitchFamily="34" charset="-120"/>
               </a:rPr>
-              <a:t>Внутренний материал · сентябрь 2026 · подготовка к разговору с вендором</a:t>
+              <a:t>Внутренний материал · сентябрь 2026 · подготовка к разговору с разработчиком</a:t>
             </a:r>
             <a:endParaRPr lang="en-US" sz="1050" dirty="0"/>
           </a:p>
@@ -5396,7 +5396,7 @@
                 <a:ea typeface="Calibri" pitchFamily="34" charset="-122"/>
                 <a:cs typeface="Calibri" pitchFamily="34" charset="-120"/>
               </a:rPr>
-              <a:t> — см. case-19, §5. Предложение дерева от этого не меняется, только это конкретное решение стоит выбрать вместе с вендором.</a:t>
+              <a:t>. Предложение дерева от этого не меняется, только это конкретное решение стоит выбрать вместе с разработчиком.</a:t>
             </a:r>
             <a:endParaRPr lang="en-US" sz="1100" dirty="0"/>
           </a:p>
@@ -7245,7 +7245,7 @@
                 <a:ea typeface="Calibri" pitchFamily="34" charset="-122"/>
                 <a:cs typeface="Calibri" pitchFamily="34" charset="-120"/>
               </a:rPr>
-              <a:t>персона привязана сразу к двум узлам — это явная множественная привязка, а не «переключение» между ролями (case-11, исправлено после разбора case-20)</a:t>
+              <a:t>персона привязана сразу к двум узлам — это явная множественная привязка, а не «переключение» между ролями</a:t>
             </a:r>
             <a:endParaRPr lang="en-US" sz="1200" dirty="0"/>
           </a:p>
@@ -7541,7 +7541,7 @@
                 <a:ea typeface="Calibri" pitchFamily="34" charset="-122"/>
                 <a:cs typeface="Calibri" pitchFamily="34" charset="-120"/>
               </a:rPr>
-              <a:t>привязан к корню — права default-узла в принципе нельзя сузить (case-19, §4.3, инвариант Purview)</a:t>
+              <a:t>привязан к корню — права default-узла в принципе нельзя сузить (тот же инвариант, что и в Microsoft Purview)</a:t>
             </a:r>
             <a:endParaRPr lang="en-US" sz="1200" dirty="0"/>
           </a:p>
@@ -7894,7 +7894,7 @@
                 <a:ea typeface="Calibri" pitchFamily="34" charset="-122"/>
                 <a:cs typeface="Calibri" pitchFamily="34" charset="-120"/>
               </a:rPr>
-              <a:t>Организацию множества плоских доменов (2b) — одной структурой, а не отдельными несвязанными доменами. Гранулярность внутри документа (2a) — отдельный, ещё открытый вопрос вендору.</a:t>
+              <a:t>Организацию множества плоских доменов (2b) — одной структурой, а не отдельными несвязанными доменами. Гранулярность внутри документа (2a) — отдельный, ещё открытый вопрос к разработчику.</a:t>
             </a:r>
             <a:endParaRPr lang="en-US" sz="1150" dirty="0"/>
           </a:p>
@@ -8056,7 +8056,7 @@
                 <a:ea typeface="Calibri" pitchFamily="34" charset="-122"/>
                 <a:cs typeface="Calibri" pitchFamily="34" charset="-120"/>
               </a:rPr>
-              <a:t>Правило «вниз, не вбок и не вверх» — задокументированное поведение Microsoft Purview («Restrict inherited permissions»), Google Drive («Limited access»), SharePoint и Databricks Unity Catalog (case-19).</a:t>
+              <a:t>Правило «вниз, не вбок и не вверх» — задокументированное поведение Microsoft Purview («Restrict inherited permissions»), Google Drive («Limited access»), SharePoint и Databricks Unity Catalog.</a:t>
             </a:r>
             <a:endParaRPr lang="en-US" sz="1150" dirty="0"/>
           </a:p>
@@ -9136,7 +9136,7 @@
                 <a:ea typeface="Calibri" pitchFamily="34" charset="-122"/>
                 <a:cs typeface="Calibri" pitchFamily="34" charset="-120"/>
               </a:rPr>
-              <a:t>Это не найденный баг и не пробел в тестировании — а естественное расширение сегодняшней модели «домен = тематическая область», подкреплённое конкретными прецедентами (case-19). Мы предлагаем включить его в дорожную карту и готовы прорабатывать детали реализации вместе с вендором.</a:t>
+              <a:t>Это не найденный баг и не пробел в тестировании — а естественное расширение сегодняшней модели «домен = тематическая область», подкреплённое конкретными прецедентами из индустрии. Предлагаю включить его в дорожную карту и готов прорабатывать детали реализации вместе с разработчиком.</a:t>
             </a:r>
             <a:endParaRPr lang="en-US" sz="1250" dirty="0"/>
           </a:p>
@@ -9707,7 +9707,7 @@
                 <a:ea typeface="Calibri" pitchFamily="34" charset="-122"/>
                 <a:cs typeface="Calibri" pitchFamily="34" charset="-120"/>
               </a:rPr>
-              <a:t>• Часть 1 — сомнение в необходимости нового места исполнения (компьютер сотрудника); ждём ответа вендора</a:t>
+              <a:t>• Часть 1 — сомнение в необходимости нового места исполнения (компьютер сотрудника); жду ответа разработчика</a:t>
             </a:r>
             <a:endParaRPr lang="en-US" sz="1200" dirty="0"/>
           </a:p>
@@ -9727,7 +9727,7 @@
                 <a:ea typeface="Calibri" pitchFamily="34" charset="-122"/>
                 <a:cs typeface="Calibri" pitchFamily="34" charset="-120"/>
               </a:rPr>
-              <a:t>• Часть 2 — предложение к реализации, снимающее ограничение плоского домена; готовы дорабатывать вместе</a:t>
+              <a:t>• Часть 2 — предложение к реализации, снимающее ограничение плоского домена; готов дорабатывать вместе с разработчиком</a:t>
             </a:r>
             <a:endParaRPr lang="en-US" sz="1200" dirty="0"/>
           </a:p>
@@ -9769,7 +9769,7 @@
                 <a:ea typeface="Calibri" pitchFamily="34" charset="-122"/>
                 <a:cs typeface="Calibri" pitchFamily="34" charset="-120"/>
               </a:rPr>
-              <a:t>Часть 1 остаётся открытым вопросом для вендора, Часть 2 — предложением к реализации. Обе позиции поднимаются проактивно, до того как РМ-1 или «Каталог»/«Надзор» станут обязательством в договоре.</a:t>
+              <a:t>Часть 1 остаётся открытым вопросом к разработчику, Часть 2 — предложением к реализации. Обе позиции поднимаются проактивно, до того как РМ-1 или «Каталог»/«Надзор» станут обязательством в договоре.</a:t>
             </a:r>
             <a:endParaRPr lang="en-US" sz="1300" dirty="0"/>
           </a:p>
@@ -9976,8 +9976,8 @@
         </p:nvSpPr>
         <p:spPr>
           <a:xfrm>
-            <a:off x="548640" y="2194560"/>
-            <a:ext cx="8503920" cy="1005840"/>
+            <a:off x="548640" y="2103120"/>
+            <a:ext cx="8686800" cy="685800"/>
           </a:xfrm>
           <a:prstGeom prst="rect">
             <a:avLst/>
@@ -9991,12 +9991,12 @@
           <a:p>
             <a:pPr indent="0" marL="0">
               <a:lnSpc>
-                <a:spcPct val="108000"/>
+                <a:spcPct val="110000"/>
               </a:lnSpc>
               <a:buNone/>
             </a:pPr>
             <a:r>
-              <a:rPr lang="en-US" sz="3000" b="1" dirty="0">
+              <a:rPr lang="en-US" sz="2700" b="1" dirty="0">
                 <a:solidFill>
                   <a:srgbClr val="FFFFFF"/>
                 </a:solidFill>
@@ -10006,7 +10006,7 @@
               </a:rPr>
               <a:t>Сомнение и предложение — в одном файле</a:t>
             </a:r>
-            <a:endParaRPr lang="en-US" sz="3000" dirty="0"/>
+            <a:endParaRPr lang="en-US" sz="2700" dirty="0"/>
           </a:p>
         </p:txBody>
       </p:sp>
@@ -10018,8 +10018,8 @@
         </p:nvSpPr>
         <p:spPr>
           <a:xfrm>
-            <a:off x="548640" y="3246120"/>
-            <a:ext cx="7863840" cy="1051560"/>
+            <a:off x="548640" y="3063240"/>
+            <a:ext cx="8503920" cy="1188720"/>
           </a:xfrm>
           <a:prstGeom prst="rect">
             <a:avLst/>
@@ -10033,12 +10033,12 @@
           <a:p>
             <a:pPr indent="0" marL="0">
               <a:lnSpc>
-                <a:spcPct val="130000"/>
+                <a:spcPct val="128000"/>
               </a:lnSpc>
               <a:buNone/>
             </a:pPr>
             <a:r>
-              <a:rPr lang="en-US" sz="1450" dirty="0">
+              <a:rPr lang="en-US" sz="1350" dirty="0">
                 <a:solidFill>
                   <a:srgbClr val="AEB4C4"/>
                 </a:solidFill>
@@ -10046,9 +10046,9 @@
                 <a:ea typeface="Calibri" pitchFamily="34" charset="-122"/>
                 <a:cs typeface="Calibri" pitchFamily="34" charset="-120"/>
               </a:rPr>
-              <a:t>Часть 1 остаётся открытым вопросом о необходимости — ждём точку зрения вендора. Часть 2 — наше предложение к реализации, готовое дорабатывать вместе. Обе позиции зафиксированы в case-11-voprosy-vendoru-roadmap.md, куда лягут ответы вендора и шаги к реализации.</a:t>
-            </a:r>
-            <a:endParaRPr lang="en-US" sz="1450" dirty="0"/>
+              <a:t>Часть 1 остаётся открытым вопросом о необходимости — жду точку зрения разработчика. Часть 2 — моё предложение к реализации, готовое дорабатывать вместе. Обе позиции зафиксированы в материалах, которые я подготовил для разговора с разработчиком, куда лягут его ответы и шаги к реализации.</a:t>
+            </a:r>
+            <a:endParaRPr lang="en-US" sz="1350" dirty="0"/>
           </a:p>
         </p:txBody>
       </p:sp>
@@ -10060,7 +10060,7 @@
         </p:nvSpPr>
         <p:spPr>
           <a:xfrm>
-            <a:off x="548640" y="4572000"/>
+            <a:off x="548640" y="4526280"/>
             <a:ext cx="7863840" cy="777240"/>
           </a:xfrm>
           <a:prstGeom prst="roundRect">
@@ -10082,7 +10082,7 @@
         </p:nvSpPr>
         <p:spPr>
           <a:xfrm>
-            <a:off x="868680" y="4572000"/>
+            <a:off x="868680" y="4526280"/>
             <a:ext cx="7315200" cy="777240"/>
           </a:xfrm>
           <a:prstGeom prst="rect">
@@ -10099,17 +10099,17 @@
               <a:buNone/>
             </a:pPr>
             <a:r>
-              <a:rPr lang="en-US" sz="1350" dirty="0">
+              <a:rPr lang="en-US" sz="1400" b="1" dirty="0">
                 <a:solidFill>
                   <a:srgbClr val="E8A33D"/>
                 </a:solidFill>
-                <a:latin typeface="Courier New" pitchFamily="34" charset="0"/>
-                <a:ea typeface="Courier New" pitchFamily="34" charset="-122"/>
-                <a:cs typeface="Courier New" pitchFamily="34" charset="-120"/>
-              </a:rPr>
-              <a:t>docs/analysis/case-11-voprosy-vendoru-roadmap.md</a:t>
-            </a:r>
-            <a:endParaRPr lang="en-US" sz="1350" dirty="0"/>
+                <a:latin typeface="Calibri" pitchFamily="34" charset="0"/>
+                <a:ea typeface="Calibri" pitchFamily="34" charset="-122"/>
+                <a:cs typeface="Calibri" pitchFamily="34" charset="-120"/>
+              </a:rPr>
+              <a:t>Вопросы и предложения к дорожной карте для разработчика</a:t>
+            </a:r>
+            <a:endParaRPr lang="en-US" sz="1400" dirty="0"/>
           </a:p>
         </p:txBody>
       </p:sp>
@@ -10855,7 +10855,7 @@
                 <a:ea typeface="Calibri" pitchFamily="34" charset="-122"/>
                 <a:cs typeface="Calibri" pitchFamily="34" charset="-120"/>
               </a:rPr>
-              <a:t>Обе позиции уже зафиксированы в </a:t>
+              <a:t>Обе позиции уже оформлены как </a:t>
             </a:r>
             <a:pPr indent="0" marL="0">
               <a:lnSpc>
@@ -10872,7 +10872,7 @@
                 <a:ea typeface="Calibri" pitchFamily="34" charset="-122"/>
                 <a:cs typeface="Calibri" pitchFamily="34" charset="-120"/>
               </a:rPr>
-              <a:t>case-11-voprosy-vendoru-roadmap.md</a:t>
+              <a:t>материал для разговора с разработчиком</a:t>
             </a:r>
             <a:pPr indent="0" marL="0">
               <a:lnSpc>
@@ -10889,7 +10889,7 @@
                 <a:ea typeface="Calibri" pitchFamily="34" charset="-122"/>
                 <a:cs typeface="Calibri" pitchFamily="34" charset="-120"/>
               </a:rPr>
-              <a:t> — Часть 1 как открытый вопрос вендору, Часть 2 как предложение к обсуждению; файл остаётся живым документом, куда лягут ответы и детали реализации.</a:t>
+              <a:t> — Часть 1 как открытый вопрос к разработчику, Часть 2 как предложение к обсуждению; материал остаётся живым документом, куда лягут ответы и детали реализации.</a:t>
             </a:r>
             <a:endParaRPr lang="en-US" sz="1200" dirty="0"/>
           </a:p>
@@ -12590,7 +12590,7 @@
                 <a:ea typeface="Calibri" pitchFamily="34" charset="-122"/>
                 <a:cs typeface="Calibri" pitchFamily="34" charset="-120"/>
               </a:rPr>
-              <a:t>ЧАСТЬ 1 · ВОПРОС ВЕНДОРУ (CASE-11, ВОПРОС 1)</a:t>
+              <a:t>ЧАСТЬ 1 · ВОПРОС К РАЗРАБОТЧИКУ</a:t>
             </a:r>
             <a:endParaRPr lang="en-US" sz="1150" dirty="0"/>
           </a:p>
@@ -12674,7 +12674,7 @@
                 <a:ea typeface="Calibri" pitchFamily="34" charset="-122"/>
                 <a:cs typeface="Calibri" pitchFamily="34" charset="-120"/>
               </a:rPr>
-              <a:t>«Явная модель запретов» РМ-1 задаёт, какие папки и файлы агенту трогать нельзя, но не описывает, что происходит с содержимым разрешённых файлов на пути к LLM. Наше сомнение в необходимости РМ-1 в текущем виде снимается или подтверждается четырьмя ответами вендора:</a:t>
+              <a:t>«Явная модель запретов» РМ-1 задаёт, какие папки и файлы агенту трогать нельзя, но не описывает, что происходит с содержимым разрешённых файлов на пути к LLM. Моё сомнение в необходимости РМ-1 в текущем виде снимается или подтверждается четырьмя ответами разработчика:</a:t>
             </a:r>
             <a:endParaRPr lang="en-US" sz="1250" dirty="0"/>
           </a:p>
@@ -14172,7 +14172,7 @@
                 <a:ea typeface="Calibri" pitchFamily="34" charset="-122"/>
                 <a:cs typeface="Calibri" pitchFamily="34" charset="-120"/>
               </a:rPr>
-              <a:t>Статус: это не рекомендация отказаться от РМ-1 — необходимость этого расширения в заявленном виде для нас пока не доказана, и ответы вендора на предыдущем слайде её снимут или подтвердят. Уровень C означает подтверждённое направление, но не обязательство по срокам — самое время спросить, пока пункт не закрепился в договоре.</a:t>
+              <a:t>Статус: это не рекомендация отказаться от РМ-1 — необходимость этого расширения в заявленном виде пока не доказана, и ответы разработчика на предыдущем слайде её снимут или подтвердят. Уровень C означает подтверждённое направление, но не обязательство по срокам — самое время спросить, пока пункт не закрепился в договоре.</a:t>
             </a:r>
             <a:endParaRPr lang="en-US" sz="1200" dirty="0"/>
           </a:p>
@@ -15339,7 +15339,7 @@
                 <a:ea typeface="Calibri" pitchFamily="34" charset="-122"/>
                 <a:cs typeface="Calibri" pitchFamily="34" charset="-120"/>
               </a:rPr>
-              <a:t>» — kamerata-overview-review.md, П3/П6</a:t>
+              <a:t>» — из документации платформы Камерата</a:t>
             </a:r>
             <a:endParaRPr lang="en-US" sz="1300" dirty="0"/>
           </a:p>
@@ -16040,7 +16040,7 @@
                 <a:ea typeface="Calibri" pitchFamily="34" charset="-122"/>
                 <a:cs typeface="Calibri" pitchFamily="34" charset="-120"/>
               </a:rPr>
-              <a:t>Это на самом деле два разных вопроса вендору (case-11, Вопрос 2): </a:t>
+              <a:t>Это на самом деле два разных вопроса к разработчику: </a:t>
             </a:r>
             <a:pPr indent="0" marL="0">
               <a:lnSpc>

</xml_diff>

<commit_message>
Fix slide 11 missing node/connector and slide 13 badge paths
Slide 11: «Оклады» node was missing from the cross-domain diagram
(only referenced in a text note) -- now drawn explicitly, matching
slide 10's style, positioned between the «Кадры» root and «Больничные»/
«Отпускные». Rerouted the «Маркетинг»/«Логистика» connector lines from
diagonals that crossed confusingly in the middle of the slide to
elbow routing down each outer edge, turning in once at «Список
сотрудников» -- no crossover.

Slide 13: node-path badges for «Сотрудник кадров» showed "Кадры /
Оклады / Больничные" -- misleading right next to the text saying she
does NOT see «Оклады», since it looked like her binding path passed
through it. Shortened to "Кадры / Больничные" / "Кадры / Отпускные".

Co-Authored-By: Claude Sonnet 5 <noreply@anthropic.com>
Claude-Session: https://claude.ai/code/session_01DpSN8JwCJ3tg3JVUadr2zE
</commit_message>
<xml_diff>
--- a/docs/presentations/case-17-lokalny-chat-i-ierarhiya-katalogov.pptx
+++ b/docs/presentations/case-17-lokalny-chat-i-ierarhiya-katalogov.pptx
@@ -695,7 +695,7 @@
           <a:p>
             <a:r>
               <a:rPr lang="en-US" dirty="0"/>
-              <a:t>Полностью пересобранный слайд под новую форму: раньше общий узел «Список сотрудников» сам был хабом с тремя детьми, теперь он — лист, и это ключевое исправление по итогам ревью. Три независимых домена верхнего уровня — «Кадры», «Маркетинг», «Логистика» (канонические примеры платформы: «Логистика», «Персонал», «Продажи») — сходятся в одну и ту же точку четырьмя путями: «Кадры» доходит до неё через свою пару сиблингов «Больничные»/«Отпускные» (узел «Оклады», который стоит выше них на предыдущем слайде, здесь сознательно не перерисован — пометка рядом с доменным блоком отсылает к слайду 10); «Маркетинг» и «Логистика» — прямым ребром от своего корня. Итого у «Список сотрудников» четыре родителя, но сам он — лист без единого потомка: это и есть структурное исправление против прежней версии, где через общий хаб зарплатные данные утекали в другие домены. Обе вещи, которые независимый ревью просил сделать явными, есть на слайде: (1) легенда-напоминание в общем баре — узел на схеме означает узел плюс все его потомки, иначе «Оклады» на предыдущем слайде легко прочитать как «только сами оклады»; (2) новый открытый вопрос к разработчику о направлении обхода — что для узла с несколькими родителями видимость гарантированно обходится только вниз от точки привязки, а родительские рёбра при проверке доступа никогда не используются, вне зависимости от числа родителей; это нужно подтвердить как реальную гарантию реализации, а не молча предполагать. Старый открытый вопрос про «Маркетинг» — весь список или только свой отдел — сохранён дословно по сути (тот же класс вопроса, что и «2a»), но явно объявлено, что раньше сопутствовавший ему риск увидеть «Оклады» через общий хаб теперь закрыт структурно, потому что общий узел — лист.</a:t>
+              <a:t>Полностью пересобранный слайд под новую форму: раньше общий узел «Список сотрудников» сам был хабом с тремя детьми, теперь он — лист, и это ключевое исправление по итогам ревью. Три независимых домена верхнего уровня — «Кадры», «Маркетинг», «Логистика» (канонические примеры платформы: «Логистика», «Персонал», «Продажи») — сходятся в одну и ту же точку четырьмя путями: «Кадры» доходит до неё через «Оклады» (тот же узел и тот же стиль отрисовки, что на слайде 10 — здесь он тоже нарисован, не только упомянут) и дальше через пару его сиблингов «Больничные»/«Отпускные»; «Маркетинг» и «Логистика» — прямым ребром от своего корня. Итого у «Список сотрудников» четыре родителя, но сам он — лист без единого потомка: это и есть структурное исправление против прежней версии, где через общий хаб зарплатные данные утекали в другие домены. Линии «Маркетинг» и «Логистика» специально разведены по внешним краям слайда (каждая идёт вертикально вниз мимо всей ветки «Кадры», затем одним поворотом входит в общий узел сбоку на высоте его середины) — это устраняет прежнее перекрестие по центру слайда, из-за которого было неясно, какая линия к какому домену относится; после добавления «Оклады» в центральную колонку такой прямой диагональный путь стал бы пересекать её ещё сильнее, поэтому геометрия впадения полностью заменена на угловую в обход. Обе вещи, которые независимый ревью просил сделать явными, есть на слайде: (1) легенда-напоминание в общем баре — узел на схеме означает узел плюс все его потомки; (2) открытый вопрос к разработчику о направлении обхода — что для узла с несколькими родителями видимость гарантированно обходится только вниз от точки привязки, а родительские рёбра при проверке доступа никогда не используются, вне зависимости от числа родителей; это нужно подтвердить как реальную гарантию реализации, а не молча предполагать. Старый открытый вопрос про «Маркетинг» — весь список или только свой отдел — сохранён дословно по сути (тот же класс вопроса, что и «2a»), но явно объявлено, что раньше сопутствовавший ему риск увидеть «Оклады» через общий хаб теперь закрыт структурно, потому что общий узел — лист.</a:t>
             </a:r>
             <a:endParaRPr lang="en-US" dirty="0"/>
           </a:p>
@@ -3964,7 +3964,7 @@
                 <a:ea typeface="Calibri" pitchFamily="34" charset="-122"/>
                 <a:cs typeface="Calibri" pitchFamily="34" charset="-120"/>
               </a:rPr>
-              <a:t>Каталог не обязан быть в одном дереве. «Список сотрудников» нужен трём доменам сразу — «Кадры» (через «Больничные»/«Отпускные»), «Маркетинг» и «Логистика» (прямым ребром от корня) — и сам является листом.</a:t>
+              <a:t>Каталог не обязан быть в одном дереве. «Список сотрудников» нужен трём доменам сразу — «Кадры» (через «Оклады» → «Больничные»/«Отпускные»), «Маркетинг» и «Логистика» (прямым ребром от корня) — и сам является листом.</a:t>
             </a:r>
             <a:endParaRPr lang="en-US" sz="1250" dirty="0"/>
           </a:p>
@@ -4203,8 +4203,8 @@
         </p:nvSpPr>
         <p:spPr>
           <a:xfrm>
-            <a:off x="7257593" y="2029968"/>
-            <a:ext cx="1417320" cy="329184"/>
+            <a:off x="10863072" y="2029968"/>
+            <a:ext cx="779983" cy="329184"/>
           </a:xfrm>
           <a:prstGeom prst="rect">
             <a:avLst/>
@@ -4231,7 +4231,7 @@
                 <a:ea typeface="Calibri" pitchFamily="34" charset="-122"/>
                 <a:cs typeface="Calibri" pitchFamily="34" charset="-120"/>
               </a:rPr>
-              <a:t>«Оклады» — выше, см. слайд 10</a:t>
+              <a:t>не всё дерево показано</a:t>
             </a:r>
             <a:endParaRPr lang="en-US" sz="800" dirty="0"/>
           </a:p>
@@ -4239,56 +4239,14 @@
       </p:sp>
       <p:sp>
         <p:nvSpPr>
-          <p:cNvPr id="13" name="Text 11"/>
-          <p:cNvSpPr/>
-          <p:nvPr/>
-        </p:nvSpPr>
-        <p:spPr>
-          <a:xfrm>
-            <a:off x="10863072" y="2029968"/>
-            <a:ext cx="779983" cy="329184"/>
-          </a:xfrm>
-          <a:prstGeom prst="rect">
-            <a:avLst/>
-          </a:prstGeom>
-          <a:noFill/>
-          <a:ln/>
-        </p:spPr>
-        <p:txBody>
-          <a:bodyPr wrap="square" lIns="0" tIns="0" rIns="0" bIns="0" rtlCol="0" anchor="ctr"/>
-          <a:lstStyle/>
-          <a:p>
-            <a:pPr algn="l" indent="0" marL="0">
-              <a:lnSpc>
-                <a:spcPct val="100000"/>
-              </a:lnSpc>
-              <a:buNone/>
-            </a:pPr>
-            <a:r>
-              <a:rPr lang="en-US" sz="800" i="1" dirty="0">
-                <a:solidFill>
-                  <a:srgbClr val="5B6472"/>
-                </a:solidFill>
-                <a:latin typeface="Calibri" pitchFamily="34" charset="0"/>
-                <a:ea typeface="Calibri" pitchFamily="34" charset="-122"/>
-                <a:cs typeface="Calibri" pitchFamily="34" charset="-120"/>
-              </a:rPr>
-              <a:t>не всё дерево показано</a:t>
-            </a:r>
-            <a:endParaRPr lang="en-US" sz="800" dirty="0"/>
-          </a:p>
-        </p:txBody>
-      </p:sp>
-      <p:sp>
-        <p:nvSpPr>
-          <p:cNvPr id="14" name="Shape 12"/>
+          <p:cNvPr id="13" name="Shape 11"/>
           <p:cNvSpPr/>
           <p:nvPr/>
         </p:nvSpPr>
         <p:spPr>
           <a:xfrm>
             <a:off x="6096305" y="2377440"/>
-            <a:ext cx="0" cy="182880"/>
+            <a:ext cx="0" cy="274320"/>
           </a:xfrm>
           <a:prstGeom prst="line">
             <a:avLst/>
@@ -4304,14 +4262,80 @@
       </p:sp>
       <p:sp>
         <p:nvSpPr>
-          <p:cNvPr id="15" name="Shape 13"/>
-          <p:cNvSpPr/>
-          <p:nvPr/>
-        </p:nvSpPr>
-        <p:spPr>
-          <a:xfrm>
-            <a:off x="5227625" y="2560320"/>
-            <a:ext cx="1737360" cy="0"/>
+          <p:cNvPr id="14" name="Shape 12"/>
+          <p:cNvSpPr/>
+          <p:nvPr/>
+        </p:nvSpPr>
+        <p:spPr>
+          <a:xfrm>
+            <a:off x="5181905" y="2651760"/>
+            <a:ext cx="1828800" cy="365760"/>
+          </a:xfrm>
+          <a:prstGeom prst="roundRect">
+            <a:avLst>
+              <a:gd name="adj" fmla="val 20000"/>
+            </a:avLst>
+          </a:prstGeom>
+          <a:solidFill>
+            <a:srgbClr val="FBEED9"/>
+          </a:solidFill>
+          <a:ln w="19050">
+            <a:solidFill>
+              <a:srgbClr val="E8A33D"/>
+            </a:solidFill>
+            <a:prstDash val="solid"/>
+          </a:ln>
+        </p:spPr>
+      </p:sp>
+      <p:sp>
+        <p:nvSpPr>
+          <p:cNvPr id="15" name="Text 13"/>
+          <p:cNvSpPr/>
+          <p:nvPr/>
+        </p:nvSpPr>
+        <p:spPr>
+          <a:xfrm>
+            <a:off x="5181905" y="2651760"/>
+            <a:ext cx="1828800" cy="365760"/>
+          </a:xfrm>
+          <a:prstGeom prst="rect">
+            <a:avLst/>
+          </a:prstGeom>
+          <a:noFill/>
+          <a:ln/>
+        </p:spPr>
+        <p:txBody>
+          <a:bodyPr wrap="square" lIns="0" tIns="0" rIns="0" bIns="0" rtlCol="0" anchor="ctr"/>
+          <a:lstStyle/>
+          <a:p>
+            <a:pPr algn="ctr" indent="0" marL="0">
+              <a:buNone/>
+            </a:pPr>
+            <a:r>
+              <a:rPr lang="en-US" sz="1300" b="1" dirty="0">
+                <a:solidFill>
+                  <a:srgbClr val="B87A1E"/>
+                </a:solidFill>
+                <a:latin typeface="Calibri" pitchFamily="34" charset="0"/>
+                <a:ea typeface="Calibri" pitchFamily="34" charset="-122"/>
+                <a:cs typeface="Calibri" pitchFamily="34" charset="-120"/>
+              </a:rPr>
+              <a:t>Оклады</a:t>
+            </a:r>
+            <a:endParaRPr lang="en-US" sz="1300" dirty="0"/>
+          </a:p>
+        </p:txBody>
+      </p:sp>
+      <p:sp>
+        <p:nvSpPr>
+          <p:cNvPr id="16" name="Shape 14"/>
+          <p:cNvSpPr/>
+          <p:nvPr/>
+        </p:nvSpPr>
+        <p:spPr>
+          <a:xfrm>
+            <a:off x="6096305" y="3017520"/>
+            <a:ext cx="0" cy="137160"/>
           </a:xfrm>
           <a:prstGeom prst="line">
             <a:avLst/>
@@ -4327,14 +4351,14 @@
       </p:sp>
       <p:sp>
         <p:nvSpPr>
-          <p:cNvPr id="16" name="Shape 14"/>
-          <p:cNvSpPr/>
-          <p:nvPr/>
-        </p:nvSpPr>
-        <p:spPr>
-          <a:xfrm>
-            <a:off x="5227625" y="2560320"/>
-            <a:ext cx="0" cy="182880"/>
+          <p:cNvPr id="17" name="Shape 15"/>
+          <p:cNvSpPr/>
+          <p:nvPr/>
+        </p:nvSpPr>
+        <p:spPr>
+          <a:xfrm>
+            <a:off x="5227625" y="3154680"/>
+            <a:ext cx="1737360" cy="0"/>
           </a:xfrm>
           <a:prstGeom prst="line">
             <a:avLst/>
@@ -4350,14 +4374,14 @@
       </p:sp>
       <p:sp>
         <p:nvSpPr>
-          <p:cNvPr id="17" name="Shape 15"/>
-          <p:cNvSpPr/>
-          <p:nvPr/>
-        </p:nvSpPr>
-        <p:spPr>
-          <a:xfrm>
-            <a:off x="6964985" y="2560320"/>
-            <a:ext cx="0" cy="182880"/>
+          <p:cNvPr id="18" name="Shape 16"/>
+          <p:cNvSpPr/>
+          <p:nvPr/>
+        </p:nvSpPr>
+        <p:spPr>
+          <a:xfrm>
+            <a:off x="5227625" y="3154680"/>
+            <a:ext cx="0" cy="137160"/>
           </a:xfrm>
           <a:prstGeom prst="line">
             <a:avLst/>
@@ -4373,18 +4397,41 @@
       </p:sp>
       <p:sp>
         <p:nvSpPr>
-          <p:cNvPr id="18" name="Shape 16"/>
-          <p:cNvSpPr/>
-          <p:nvPr/>
-        </p:nvSpPr>
-        <p:spPr>
-          <a:xfrm>
-            <a:off x="4404665" y="2743200"/>
-            <a:ext cx="1645920" cy="420624"/>
+          <p:cNvPr id="19" name="Shape 17"/>
+          <p:cNvSpPr/>
+          <p:nvPr/>
+        </p:nvSpPr>
+        <p:spPr>
+          <a:xfrm>
+            <a:off x="6964985" y="3154680"/>
+            <a:ext cx="0" cy="137160"/>
+          </a:xfrm>
+          <a:prstGeom prst="line">
+            <a:avLst/>
+          </a:prstGeom>
+          <a:noFill/>
+          <a:ln w="19050">
+            <a:solidFill>
+              <a:srgbClr val="8891A0"/>
+            </a:solidFill>
+            <a:prstDash val="solid"/>
+          </a:ln>
+        </p:spPr>
+      </p:sp>
+      <p:sp>
+        <p:nvSpPr>
+          <p:cNvPr id="20" name="Shape 18"/>
+          <p:cNvSpPr/>
+          <p:nvPr/>
+        </p:nvSpPr>
+        <p:spPr>
+          <a:xfrm>
+            <a:off x="4404665" y="3291840"/>
+            <a:ext cx="1645920" cy="384048"/>
           </a:xfrm>
           <a:prstGeom prst="roundRect">
             <a:avLst>
-              <a:gd name="adj" fmla="val 17391"/>
+              <a:gd name="adj" fmla="val 19048"/>
             </a:avLst>
           </a:prstGeom>
           <a:solidFill>
@@ -4400,14 +4447,14 @@
       </p:sp>
       <p:sp>
         <p:nvSpPr>
-          <p:cNvPr id="19" name="Text 17"/>
-          <p:cNvSpPr/>
-          <p:nvPr/>
-        </p:nvSpPr>
-        <p:spPr>
-          <a:xfrm>
-            <a:off x="4404665" y="2743200"/>
-            <a:ext cx="1645920" cy="420624"/>
+          <p:cNvPr id="21" name="Text 19"/>
+          <p:cNvSpPr/>
+          <p:nvPr/>
+        </p:nvSpPr>
+        <p:spPr>
+          <a:xfrm>
+            <a:off x="4404665" y="3291840"/>
+            <a:ext cx="1645920" cy="384048"/>
           </a:xfrm>
           <a:prstGeom prst="rect">
             <a:avLst/>
@@ -4439,18 +4486,18 @@
       </p:sp>
       <p:sp>
         <p:nvSpPr>
-          <p:cNvPr id="20" name="Shape 18"/>
-          <p:cNvSpPr/>
-          <p:nvPr/>
-        </p:nvSpPr>
-        <p:spPr>
-          <a:xfrm>
-            <a:off x="6142025" y="2743200"/>
-            <a:ext cx="1645920" cy="420624"/>
+          <p:cNvPr id="22" name="Shape 20"/>
+          <p:cNvSpPr/>
+          <p:nvPr/>
+        </p:nvSpPr>
+        <p:spPr>
+          <a:xfrm>
+            <a:off x="6142025" y="3291840"/>
+            <a:ext cx="1645920" cy="384048"/>
           </a:xfrm>
           <a:prstGeom prst="roundRect">
             <a:avLst>
-              <a:gd name="adj" fmla="val 17391"/>
+              <a:gd name="adj" fmla="val 19048"/>
             </a:avLst>
           </a:prstGeom>
           <a:solidFill>
@@ -4466,14 +4513,14 @@
       </p:sp>
       <p:sp>
         <p:nvSpPr>
-          <p:cNvPr id="21" name="Text 19"/>
-          <p:cNvSpPr/>
-          <p:nvPr/>
-        </p:nvSpPr>
-        <p:spPr>
-          <a:xfrm>
-            <a:off x="6142025" y="2743200"/>
-            <a:ext cx="1645920" cy="420624"/>
+          <p:cNvPr id="23" name="Text 21"/>
+          <p:cNvSpPr/>
+          <p:nvPr/>
+        </p:nvSpPr>
+        <p:spPr>
+          <a:xfrm>
+            <a:off x="6142025" y="3291840"/>
+            <a:ext cx="1645920" cy="384048"/>
           </a:xfrm>
           <a:prstGeom prst="rect">
             <a:avLst/>
@@ -4505,14 +4552,14 @@
       </p:sp>
       <p:sp>
         <p:nvSpPr>
-          <p:cNvPr id="22" name="Shape 20"/>
-          <p:cNvSpPr/>
-          <p:nvPr/>
-        </p:nvSpPr>
-        <p:spPr>
-          <a:xfrm>
-            <a:off x="5227625" y="3163824"/>
-            <a:ext cx="0" cy="315468"/>
+          <p:cNvPr id="24" name="Shape 22"/>
+          <p:cNvSpPr/>
+          <p:nvPr/>
+        </p:nvSpPr>
+        <p:spPr>
+          <a:xfrm>
+            <a:off x="5227625" y="3675888"/>
+            <a:ext cx="0" cy="137160"/>
           </a:xfrm>
           <a:prstGeom prst="line">
             <a:avLst/>
@@ -4528,14 +4575,14 @@
       </p:sp>
       <p:sp>
         <p:nvSpPr>
-          <p:cNvPr id="23" name="Shape 21"/>
-          <p:cNvSpPr/>
-          <p:nvPr/>
-        </p:nvSpPr>
-        <p:spPr>
-          <a:xfrm>
-            <a:off x="6964985" y="3163824"/>
-            <a:ext cx="0" cy="315468"/>
+          <p:cNvPr id="25" name="Shape 23"/>
+          <p:cNvSpPr/>
+          <p:nvPr/>
+        </p:nvSpPr>
+        <p:spPr>
+          <a:xfrm>
+            <a:off x="6964985" y="3675888"/>
+            <a:ext cx="0" cy="137160"/>
           </a:xfrm>
           <a:prstGeom prst="line">
             <a:avLst/>
@@ -4551,13 +4598,13 @@
       </p:sp>
       <p:sp>
         <p:nvSpPr>
-          <p:cNvPr id="24" name="Shape 22"/>
-          <p:cNvSpPr/>
-          <p:nvPr/>
-        </p:nvSpPr>
-        <p:spPr>
-          <a:xfrm>
-            <a:off x="5227625" y="3479292"/>
+          <p:cNvPr id="26" name="Shape 24"/>
+          <p:cNvSpPr/>
+          <p:nvPr/>
+        </p:nvSpPr>
+        <p:spPr>
+          <a:xfrm>
+            <a:off x="5227625" y="3813048"/>
             <a:ext cx="1737360" cy="0"/>
           </a:xfrm>
           <a:prstGeom prst="line">
@@ -4574,14 +4621,14 @@
       </p:sp>
       <p:sp>
         <p:nvSpPr>
-          <p:cNvPr id="25" name="Shape 23"/>
-          <p:cNvSpPr/>
-          <p:nvPr/>
-        </p:nvSpPr>
-        <p:spPr>
-          <a:xfrm>
-            <a:off x="6096305" y="3479292"/>
-            <a:ext cx="0" cy="315468"/>
+          <p:cNvPr id="27" name="Shape 25"/>
+          <p:cNvSpPr/>
+          <p:nvPr/>
+        </p:nvSpPr>
+        <p:spPr>
+          <a:xfrm>
+            <a:off x="6096305" y="3813048"/>
+            <a:ext cx="0" cy="137160"/>
           </a:xfrm>
           <a:prstGeom prst="line">
             <a:avLst/>
@@ -4597,14 +4644,14 @@
       </p:sp>
       <p:sp>
         <p:nvSpPr>
-          <p:cNvPr id="26" name="Shape 24"/>
+          <p:cNvPr id="28" name="Shape 26"/>
           <p:cNvSpPr/>
           <p:nvPr/>
         </p:nvSpPr>
         <p:spPr>
           <a:xfrm>
             <a:off x="2468880" y="2377440"/>
-            <a:ext cx="2667305" cy="1417320"/>
+            <a:ext cx="0" cy="1801368"/>
           </a:xfrm>
           <a:prstGeom prst="line">
             <a:avLst/>
@@ -4620,14 +4667,14 @@
       </p:sp>
       <p:sp>
         <p:nvSpPr>
-          <p:cNvPr id="27" name="Shape 25"/>
-          <p:cNvSpPr/>
-          <p:nvPr/>
-        </p:nvSpPr>
-        <p:spPr>
-          <a:xfrm>
-            <a:off x="7056425" y="2377440"/>
-            <a:ext cx="2663647" cy="1417320"/>
+          <p:cNvPr id="29" name="Shape 27"/>
+          <p:cNvSpPr/>
+          <p:nvPr/>
+        </p:nvSpPr>
+        <p:spPr>
+          <a:xfrm>
+            <a:off x="2468880" y="4178808"/>
+            <a:ext cx="2301545" cy="0"/>
           </a:xfrm>
           <a:prstGeom prst="line">
             <a:avLst/>
@@ -4643,18 +4690,64 @@
       </p:sp>
       <p:sp>
         <p:nvSpPr>
-          <p:cNvPr id="28" name="Shape 26"/>
-          <p:cNvSpPr/>
-          <p:nvPr/>
-        </p:nvSpPr>
-        <p:spPr>
-          <a:xfrm>
-            <a:off x="4770425" y="3794760"/>
-            <a:ext cx="2651760" cy="502920"/>
+          <p:cNvPr id="30" name="Shape 28"/>
+          <p:cNvSpPr/>
+          <p:nvPr/>
+        </p:nvSpPr>
+        <p:spPr>
+          <a:xfrm>
+            <a:off x="9720072" y="2377440"/>
+            <a:ext cx="0" cy="1801368"/>
+          </a:xfrm>
+          <a:prstGeom prst="line">
+            <a:avLst/>
+          </a:prstGeom>
+          <a:noFill/>
+          <a:ln w="25400">
+            <a:solidFill>
+              <a:srgbClr val="2F6FED"/>
+            </a:solidFill>
+            <a:prstDash val="solid"/>
+          </a:ln>
+        </p:spPr>
+      </p:sp>
+      <p:sp>
+        <p:nvSpPr>
+          <p:cNvPr id="31" name="Shape 29"/>
+          <p:cNvSpPr/>
+          <p:nvPr/>
+        </p:nvSpPr>
+        <p:spPr>
+          <a:xfrm>
+            <a:off x="7422185" y="4178808"/>
+            <a:ext cx="2297887" cy="0"/>
+          </a:xfrm>
+          <a:prstGeom prst="line">
+            <a:avLst/>
+          </a:prstGeom>
+          <a:noFill/>
+          <a:ln w="25400">
+            <a:solidFill>
+              <a:srgbClr val="2F6FED"/>
+            </a:solidFill>
+            <a:prstDash val="solid"/>
+          </a:ln>
+        </p:spPr>
+      </p:sp>
+      <p:sp>
+        <p:nvSpPr>
+          <p:cNvPr id="32" name="Shape 30"/>
+          <p:cNvSpPr/>
+          <p:nvPr/>
+        </p:nvSpPr>
+        <p:spPr>
+          <a:xfrm>
+            <a:off x="4770425" y="3950208"/>
+            <a:ext cx="2651760" cy="457200"/>
           </a:xfrm>
           <a:prstGeom prst="roundRect">
             <a:avLst>
-              <a:gd name="adj" fmla="val 16364"/>
+              <a:gd name="adj" fmla="val 18000"/>
             </a:avLst>
           </a:prstGeom>
           <a:solidFill>
@@ -4670,14 +4763,14 @@
       </p:sp>
       <p:sp>
         <p:nvSpPr>
-          <p:cNvPr id="29" name="Text 27"/>
-          <p:cNvSpPr/>
-          <p:nvPr/>
-        </p:nvSpPr>
-        <p:spPr>
-          <a:xfrm>
-            <a:off x="4770425" y="3794760"/>
-            <a:ext cx="2651760" cy="502920"/>
+          <p:cNvPr id="33" name="Text 31"/>
+          <p:cNvSpPr/>
+          <p:nvPr/>
+        </p:nvSpPr>
+        <p:spPr>
+          <a:xfrm>
+            <a:off x="4770425" y="3950208"/>
+            <a:ext cx="2651760" cy="457200"/>
           </a:xfrm>
           <a:prstGeom prst="rect">
             <a:avLst/>
@@ -4709,18 +4802,18 @@
       </p:sp>
       <p:sp>
         <p:nvSpPr>
-          <p:cNvPr id="30" name="Shape 28"/>
-          <p:cNvSpPr/>
-          <p:nvPr/>
-        </p:nvSpPr>
-        <p:spPr>
-          <a:xfrm>
-            <a:off x="548640" y="4407408"/>
-            <a:ext cx="11094415" cy="502920"/>
+          <p:cNvPr id="34" name="Shape 32"/>
+          <p:cNvSpPr/>
+          <p:nvPr/>
+        </p:nvSpPr>
+        <p:spPr>
+          <a:xfrm>
+            <a:off x="548640" y="4517136"/>
+            <a:ext cx="11094415" cy="457200"/>
           </a:xfrm>
           <a:prstGeom prst="roundRect">
             <a:avLst>
-              <a:gd name="adj" fmla="val 16364"/>
+              <a:gd name="adj" fmla="val 18000"/>
             </a:avLst>
           </a:prstGeom>
           <a:solidFill>
@@ -4736,14 +4829,14 @@
       </p:sp>
       <p:sp>
         <p:nvSpPr>
-          <p:cNvPr id="31" name="Text 29"/>
-          <p:cNvSpPr/>
-          <p:nvPr/>
-        </p:nvSpPr>
-        <p:spPr>
-          <a:xfrm>
-            <a:off x="777240" y="4407408"/>
-            <a:ext cx="10637215" cy="502920"/>
+          <p:cNvPr id="35" name="Text 33"/>
+          <p:cNvSpPr/>
+          <p:nvPr/>
+        </p:nvSpPr>
+        <p:spPr>
+          <a:xfrm>
+            <a:off x="777240" y="4517136"/>
+            <a:ext cx="10637215" cy="457200"/>
           </a:xfrm>
           <a:prstGeom prst="rect">
             <a:avLst/>
@@ -4795,18 +4888,18 @@
       </p:sp>
       <p:sp>
         <p:nvSpPr>
-          <p:cNvPr id="32" name="Shape 30"/>
-          <p:cNvSpPr/>
-          <p:nvPr/>
-        </p:nvSpPr>
-        <p:spPr>
-          <a:xfrm>
-            <a:off x="548640" y="5001768"/>
-            <a:ext cx="11094415" cy="1188720"/>
+          <p:cNvPr id="36" name="Shape 34"/>
+          <p:cNvSpPr/>
+          <p:nvPr/>
+        </p:nvSpPr>
+        <p:spPr>
+          <a:xfrm>
+            <a:off x="548640" y="5065776"/>
+            <a:ext cx="11094415" cy="1143000"/>
           </a:xfrm>
           <a:prstGeom prst="roundRect">
             <a:avLst>
-              <a:gd name="adj" fmla="val 6923"/>
+              <a:gd name="adj" fmla="val 7200"/>
             </a:avLst>
           </a:prstGeom>
           <a:solidFill>
@@ -4822,13 +4915,13 @@
       </p:sp>
       <p:sp>
         <p:nvSpPr>
-          <p:cNvPr id="33" name="Shape 31"/>
-          <p:cNvSpPr/>
-          <p:nvPr/>
-        </p:nvSpPr>
-        <p:spPr>
-          <a:xfrm>
-            <a:off x="777240" y="5321808"/>
+          <p:cNvPr id="37" name="Shape 35"/>
+          <p:cNvSpPr/>
+          <p:nvPr/>
+        </p:nvSpPr>
+        <p:spPr>
+          <a:xfrm>
+            <a:off x="777240" y="5362956"/>
             <a:ext cx="548640" cy="548640"/>
           </a:xfrm>
           <a:prstGeom prst="ellipse">
@@ -4842,7 +4935,7 @@
       </p:sp>
       <p:pic>
         <p:nvPicPr>
-          <p:cNvPr id="34" name="Image 0" descr="preencoded.png">    </p:cNvPr>
+          <p:cNvPr id="38" name="Image 0" descr="preencoded.png">    </p:cNvPr>
           <p:cNvPicPr>
             <a:picLocks noChangeAspect="1"/>
           </p:cNvPicPr>
@@ -4856,7 +4949,7 @@
         </p:blipFill>
         <p:spPr>
           <a:xfrm>
-            <a:off x="908914" y="5453482"/>
+            <a:off x="908914" y="5494630"/>
             <a:ext cx="285293" cy="285293"/>
           </a:xfrm>
           <a:prstGeom prst="rect">
@@ -4866,14 +4959,14 @@
       </p:pic>
       <p:sp>
         <p:nvSpPr>
-          <p:cNvPr id="35" name="Text 32"/>
-          <p:cNvSpPr/>
-          <p:nvPr/>
-        </p:nvSpPr>
-        <p:spPr>
-          <a:xfrm>
-            <a:off x="1463040" y="5111496"/>
-            <a:ext cx="9905695" cy="969264"/>
+          <p:cNvPr id="39" name="Text 36"/>
+          <p:cNvSpPr/>
+          <p:nvPr/>
+        </p:nvSpPr>
+        <p:spPr>
+          <a:xfrm>
+            <a:off x="1463040" y="5175504"/>
+            <a:ext cx="9905695" cy="923544"/>
           </a:xfrm>
           <a:prstGeom prst="rect">
             <a:avLst/>
@@ -4976,7 +5069,7 @@
       </p:sp>
       <p:sp>
         <p:nvSpPr>
-          <p:cNvPr id="36" name="Text 33"/>
+          <p:cNvPr id="40" name="Text 37"/>
           <p:cNvSpPr/>
           <p:nvPr/>
         </p:nvSpPr>
@@ -5015,7 +5108,7 @@
       </p:sp>
       <p:sp>
         <p:nvSpPr>
-          <p:cNvPr id="37" name="Text 34"/>
+          <p:cNvPr id="41" name="Text 38"/>
           <p:cNvSpPr/>
           <p:nvPr/>
         </p:nvSpPr>
@@ -6342,7 +6435,7 @@
                 <a:ea typeface="Calibri" pitchFamily="34" charset="-122"/>
                 <a:cs typeface="Calibri" pitchFamily="34" charset="-120"/>
               </a:rPr>
-              <a:t>Кадры / Оклады / Больничные</a:t>
+              <a:t>Кадры / Больничные</a:t>
             </a:r>
             <a:endParaRPr lang="en-US" sz="950" dirty="0"/>
           </a:p>
@@ -6403,7 +6496,7 @@
                 <a:ea typeface="Calibri" pitchFamily="34" charset="-122"/>
                 <a:cs typeface="Calibri" pitchFamily="34" charset="-120"/>
               </a:rPr>
-              <a:t>Кадры / Оклады / Отпускные</a:t>
+              <a:t>Кадры / Отпускные</a:t>
             </a:r>
             <a:endParaRPr lang="en-US" sz="950" dirty="0"/>
           </a:p>

</xml_diff>